<commit_message>
Rewrite Chapter 1 with complete bilingual derivations
</commit_message>
<xml_diff>
--- a/assets/figures-editable/c1-c2/c1-e13.pptx
+++ b/assets/figures-editable/c1-c2/c1-e13.pptx
@@ -3131,525 +3131,21 @@
                 </a:solidFill>
                 <a:latin typeface="Arial"/>
               </a:rPr>
-              <a:t>C1-E13 · Idealized collapse initial-value problem</a:t>
-            </a:r>
-          </a:p>
-        </p:txBody>
-      </p:sp>
-      <p:sp>
-        <p:nvSpPr>
-          <p:cNvPr id="3" name="C1-E13 round_rect 1" descr="sci-ppt:o001"/>
-          <p:cNvSpPr/>
-          <p:nvPr/>
-        </p:nvSpPr>
-        <p:spPr>
-          <a:xfrm>
-            <a:off x="365760" y="914400"/>
-            <a:ext cx="4206240" cy="5029200"/>
-          </a:xfrm>
-          <a:prstGeom prst="roundRect">
-            <a:avLst/>
-          </a:prstGeom>
-          <a:solidFill>
-            <a:srgbClr val="213E4B"/>
-          </a:solidFill>
-          <a:ln w="20320">
-            <a:solidFill>
-              <a:srgbClr val="8EDBD4"/>
-            </a:solidFill>
-          </a:ln>
-          <a:effectLst/>
-        </p:spPr>
-        <p:txBody>
-          <a:bodyPr rtlCol="0" anchor="ctr"/>
-          <a:lstStyle/>
-          <a:p>
-            <a:pPr algn="ctr"/>
-          </a:p>
-        </p:txBody>
-      </p:sp>
-      <p:sp>
-        <p:nvSpPr>
-          <p:cNvPr id="4" name="C1-E13 text 2" descr="sci-ppt:o002"/>
-          <p:cNvSpPr txBox="1"/>
-          <p:nvPr/>
-        </p:nvSpPr>
-        <p:spPr>
-          <a:xfrm>
-            <a:off x="475488" y="969264"/>
-            <a:ext cx="3986783" cy="254889"/>
-          </a:xfrm>
-          <a:prstGeom prst="rect">
-            <a:avLst/>
-          </a:prstGeom>
-          <a:noFill/>
-          <a:effectLst/>
-        </p:spPr>
-        <p:txBody>
-          <a:bodyPr wrap="none" lIns="18288" rIns="18288" tIns="18288" bIns="18288" anchor="t">
-            <a:spAutoFit/>
-          </a:bodyPr>
-          <a:lstStyle/>
-          <a:p>
-            <a:pPr algn="l">
-              <a:spcAft>
-                <a:spcPts val="0"/>
-              </a:spcAft>
-            </a:pPr>
-            <a:r>
-              <a:rPr sz="1350" b="1" i="0">
-                <a:solidFill>
-                  <a:srgbClr val="8EDBD4"/>
-                </a:solidFill>
-                <a:latin typeface="Arial"/>
-              </a:rPr>
-              <a:t>Ideal collapse, starting at rest</a:t>
-            </a:r>
-          </a:p>
-        </p:txBody>
-      </p:sp>
-      <p:sp>
-        <p:nvSpPr>
-          <p:cNvPr id="5" name="C1-E13 ellipse 3" descr="sci-ppt:o003"/>
-          <p:cNvSpPr/>
-          <p:nvPr/>
-        </p:nvSpPr>
-        <p:spPr>
-          <a:xfrm>
-            <a:off x="1417320" y="2240280"/>
-            <a:ext cx="2103120" cy="2103120"/>
-          </a:xfrm>
-          <a:prstGeom prst="ellipse">
-            <a:avLst/>
-          </a:prstGeom>
-          <a:solidFill>
-            <a:srgbClr val="1E4A5A"/>
-          </a:solidFill>
-          <a:ln w="15240">
-            <a:solidFill>
-              <a:srgbClr val="2B6678"/>
-            </a:solidFill>
-          </a:ln>
-          <a:effectLst/>
-        </p:spPr>
-        <p:txBody>
-          <a:bodyPr rtlCol="0" anchor="ctr"/>
-          <a:lstStyle/>
-          <a:p>
-            <a:pPr algn="ctr"/>
-          </a:p>
-        </p:txBody>
-      </p:sp>
-      <p:sp>
-        <p:nvSpPr>
-          <p:cNvPr id="6" name="C1-E13 ellipse 4" descr="sci-ppt:o004"/>
-          <p:cNvSpPr/>
-          <p:nvPr/>
-        </p:nvSpPr>
-        <p:spPr>
-          <a:xfrm>
-            <a:off x="1554480" y="2377440"/>
-            <a:ext cx="1828800" cy="1828800"/>
-          </a:xfrm>
-          <a:prstGeom prst="ellipse">
-            <a:avLst/>
-          </a:prstGeom>
-          <a:solidFill>
-            <a:srgbClr val="0C1820"/>
-          </a:solidFill>
-          <a:ln w="27940">
-            <a:solidFill>
-              <a:srgbClr val="F2B880"/>
-            </a:solidFill>
-          </a:ln>
-          <a:effectLst/>
-        </p:spPr>
-        <p:txBody>
-          <a:bodyPr rtlCol="0" anchor="ctr"/>
-          <a:lstStyle/>
-          <a:p>
-            <a:pPr algn="ctr"/>
-          </a:p>
-        </p:txBody>
-      </p:sp>
-      <p:sp>
-        <p:nvSpPr>
-          <p:cNvPr id="7" name="C1-E13 text 5" descr="sci-ppt:o005"/>
-          <p:cNvSpPr txBox="1"/>
-          <p:nvPr/>
-        </p:nvSpPr>
-        <p:spPr>
-          <a:xfrm>
-            <a:off x="1737360" y="2944368"/>
-            <a:ext cx="1463040" cy="239395"/>
-          </a:xfrm>
-          <a:prstGeom prst="rect">
-            <a:avLst/>
-          </a:prstGeom>
-          <a:noFill/>
-          <a:effectLst/>
-        </p:spPr>
-        <p:txBody>
-          <a:bodyPr wrap="none" lIns="18288" rIns="18288" tIns="18288" bIns="18288" anchor="t">
-            <a:spAutoFit/>
-          </a:bodyPr>
-          <a:lstStyle/>
-          <a:p>
-            <a:pPr algn="ctr">
-              <a:spcAft>
-                <a:spcPts val="0"/>
-              </a:spcAft>
-            </a:pPr>
-            <a:r>
-              <a:rPr sz="1250" b="0" i="0">
-                <a:solidFill>
-                  <a:srgbClr val="B4C7D2"/>
-                </a:solidFill>
-                <a:latin typeface="Arial"/>
-              </a:rPr>
-              <a:t>pᵥ only</a:t>
-            </a:r>
-          </a:p>
-        </p:txBody>
-      </p:sp>
-      <p:sp>
-        <p:nvSpPr>
-          <p:cNvPr id="8" name="C1-E13 text 6" descr="sci-ppt:o006"/>
-          <p:cNvSpPr txBox="1"/>
-          <p:nvPr/>
-        </p:nvSpPr>
-        <p:spPr>
-          <a:xfrm>
-            <a:off x="1737360" y="3246120"/>
-            <a:ext cx="1463040" cy="239395"/>
-          </a:xfrm>
-          <a:prstGeom prst="rect">
-            <a:avLst/>
-          </a:prstGeom>
-          <a:noFill/>
-          <a:effectLst/>
-        </p:spPr>
-        <p:txBody>
-          <a:bodyPr wrap="none" lIns="18288" rIns="18288" tIns="18288" bIns="18288" anchor="t">
-            <a:spAutoFit/>
-          </a:bodyPr>
-          <a:lstStyle/>
-          <a:p>
-            <a:pPr algn="ctr">
-              <a:spcAft>
-                <a:spcPts val="0"/>
-              </a:spcAft>
-            </a:pPr>
-            <a:r>
-              <a:rPr sz="1250" b="1" i="0">
-                <a:solidFill>
-                  <a:srgbClr val="F2B880"/>
-                </a:solidFill>
-                <a:latin typeface="Arial"/>
-              </a:rPr>
-              <a:t>R(0) = Rₘₐₓ</a:t>
-            </a:r>
-          </a:p>
-        </p:txBody>
-      </p:sp>
-      <p:sp>
-        <p:nvSpPr>
-          <p:cNvPr id="9" name="C1-E13 text 7" descr="sci-ppt:o007"/>
-          <p:cNvSpPr txBox="1"/>
-          <p:nvPr/>
-        </p:nvSpPr>
-        <p:spPr>
-          <a:xfrm>
-            <a:off x="1737360" y="3547872"/>
-            <a:ext cx="1463040" cy="239395"/>
-          </a:xfrm>
-          <a:prstGeom prst="rect">
-            <a:avLst/>
-          </a:prstGeom>
-          <a:noFill/>
-          <a:effectLst/>
-        </p:spPr>
-        <p:txBody>
-          <a:bodyPr wrap="none" lIns="18288" rIns="18288" tIns="18288" bIns="18288" anchor="t">
-            <a:spAutoFit/>
-          </a:bodyPr>
-          <a:lstStyle/>
-          <a:p>
-            <a:pPr algn="ctr">
-              <a:spcAft>
-                <a:spcPts val="0"/>
-              </a:spcAft>
-            </a:pPr>
-            <a:r>
-              <a:rPr sz="1250" b="1" i="0">
-                <a:solidFill>
-                  <a:srgbClr val="F2B880"/>
-                </a:solidFill>
-                <a:latin typeface="Arial"/>
-              </a:rPr>
-              <a:t>Ṙ(0) = 0</a:t>
+              <a:t>C1-E13 · Exact chain rule and integrating factor</a:t>
             </a:r>
           </a:p>
         </p:txBody>
       </p:sp>
       <p:cxnSp>
         <p:nvCxnSpPr>
-          <p:cNvPr id="10" name="C1-E13 arrow 8" descr="sci-ppt:o008"/>
+          <p:cNvPr id="3" name="C1-E13 line 1" descr="sci-ppt:o001"/>
           <p:cNvCxnSpPr/>
           <p:nvPr/>
         </p:nvCxnSpPr>
         <p:spPr>
-          <a:xfrm flipH="1">
-            <a:off x="3657600" y="3291840"/>
-            <a:ext cx="594360" cy="0"/>
-          </a:xfrm>
-          <a:prstGeom prst="line">
-            <a:avLst/>
-          </a:prstGeom>
-          <a:ln w="30480">
-            <a:solidFill>
-              <a:srgbClr val="8EDBD4"/>
-            </a:solidFill>
-            <a:headEnd type="none" w="med" len="med"/>
-            <a:tailEnd type="triangle" w="med" len="med"/>
-          </a:ln>
-          <a:effectLst/>
-        </p:spPr>
-      </p:cxnSp>
-      <p:cxnSp>
-        <p:nvCxnSpPr>
-          <p:cNvPr id="11" name="C1-E13 arrow 9" descr="sci-ppt:o009"/>
-          <p:cNvCxnSpPr/>
-          <p:nvPr/>
-        </p:nvCxnSpPr>
-        <p:spPr>
-          <a:xfrm flipH="1">
-            <a:off x="3309431" y="2031012"/>
-            <a:ext cx="420276" cy="420276"/>
-          </a:xfrm>
-          <a:prstGeom prst="line">
-            <a:avLst/>
-          </a:prstGeom>
-          <a:ln w="30480">
-            <a:solidFill>
-              <a:srgbClr val="8EDBD4"/>
-            </a:solidFill>
-            <a:headEnd type="none" w="med" len="med"/>
-            <a:tailEnd type="triangle" w="med" len="med"/>
-          </a:ln>
-          <a:effectLst/>
-        </p:spPr>
-      </p:cxnSp>
-      <p:cxnSp>
-        <p:nvCxnSpPr>
-          <p:cNvPr id="12" name="C1-E13 arrow 10" descr="sci-ppt:o010"/>
-          <p:cNvCxnSpPr/>
-          <p:nvPr/>
-        </p:nvCxnSpPr>
-        <p:spPr>
-          <a:xfrm>
-            <a:off x="2468880" y="1508760"/>
-            <a:ext cx="0" cy="594360"/>
-          </a:xfrm>
-          <a:prstGeom prst="line">
-            <a:avLst/>
-          </a:prstGeom>
-          <a:ln w="30480">
-            <a:solidFill>
-              <a:srgbClr val="8EDBD4"/>
-            </a:solidFill>
-            <a:headEnd type="none" w="med" len="med"/>
-            <a:tailEnd type="triangle" w="med" len="med"/>
-          </a:ln>
-          <a:effectLst/>
-        </p:spPr>
-      </p:cxnSp>
-      <p:cxnSp>
-        <p:nvCxnSpPr>
-          <p:cNvPr id="13" name="C1-E13 arrow 11" descr="sci-ppt:o011"/>
-          <p:cNvCxnSpPr/>
-          <p:nvPr/>
-        </p:nvCxnSpPr>
-        <p:spPr>
-          <a:xfrm>
-            <a:off x="1208052" y="2031012"/>
-            <a:ext cx="420276" cy="420276"/>
-          </a:xfrm>
-          <a:prstGeom prst="line">
-            <a:avLst/>
-          </a:prstGeom>
-          <a:ln w="30480">
-            <a:solidFill>
-              <a:srgbClr val="8EDBD4"/>
-            </a:solidFill>
-            <a:headEnd type="none" w="med" len="med"/>
-            <a:tailEnd type="triangle" w="med" len="med"/>
-          </a:ln>
-          <a:effectLst/>
-        </p:spPr>
-      </p:cxnSp>
-      <p:cxnSp>
-        <p:nvCxnSpPr>
-          <p:cNvPr id="14" name="C1-E13 arrow 12" descr="sci-ppt:o012"/>
-          <p:cNvCxnSpPr/>
-          <p:nvPr/>
-        </p:nvCxnSpPr>
-        <p:spPr>
-          <a:xfrm>
-            <a:off x="685800" y="3291839"/>
-            <a:ext cx="594360" cy="1"/>
-          </a:xfrm>
-          <a:prstGeom prst="line">
-            <a:avLst/>
-          </a:prstGeom>
-          <a:ln w="30480">
-            <a:solidFill>
-              <a:srgbClr val="8EDBD4"/>
-            </a:solidFill>
-            <a:headEnd type="none" w="med" len="med"/>
-            <a:tailEnd type="triangle" w="med" len="med"/>
-          </a:ln>
-          <a:effectLst/>
-        </p:spPr>
-      </p:cxnSp>
-      <p:cxnSp>
-        <p:nvCxnSpPr>
-          <p:cNvPr id="15" name="C1-E13 arrow 13" descr="sci-ppt:o013"/>
-          <p:cNvCxnSpPr/>
-          <p:nvPr/>
-        </p:nvCxnSpPr>
-        <p:spPr>
-          <a:xfrm flipV="1">
-            <a:off x="1208052" y="4132391"/>
-            <a:ext cx="420276" cy="420276"/>
-          </a:xfrm>
-          <a:prstGeom prst="line">
-            <a:avLst/>
-          </a:prstGeom>
-          <a:ln w="30480">
-            <a:solidFill>
-              <a:srgbClr val="8EDBD4"/>
-            </a:solidFill>
-            <a:headEnd type="none" w="med" len="med"/>
-            <a:tailEnd type="triangle" w="med" len="med"/>
-          </a:ln>
-          <a:effectLst/>
-        </p:spPr>
-      </p:cxnSp>
-      <p:cxnSp>
-        <p:nvCxnSpPr>
-          <p:cNvPr id="16" name="C1-E13 arrow 14" descr="sci-ppt:o014"/>
-          <p:cNvCxnSpPr/>
-          <p:nvPr/>
-        </p:nvCxnSpPr>
-        <p:spPr>
-          <a:xfrm flipV="1">
-            <a:off x="2468879" y="4480560"/>
-            <a:ext cx="0" cy="594360"/>
-          </a:xfrm>
-          <a:prstGeom prst="line">
-            <a:avLst/>
-          </a:prstGeom>
-          <a:ln w="30480">
-            <a:solidFill>
-              <a:srgbClr val="8EDBD4"/>
-            </a:solidFill>
-            <a:headEnd type="none" w="med" len="med"/>
-            <a:tailEnd type="triangle" w="med" len="med"/>
-          </a:ln>
-          <a:effectLst/>
-        </p:spPr>
-      </p:cxnSp>
-      <p:cxnSp>
-        <p:nvCxnSpPr>
-          <p:cNvPr id="17" name="C1-E13 arrow 15" descr="sci-ppt:o015"/>
-          <p:cNvCxnSpPr/>
-          <p:nvPr/>
-        </p:nvCxnSpPr>
-        <p:spPr>
-          <a:xfrm flipH="1" flipV="1">
-            <a:off x="3309431" y="4132391"/>
-            <a:ext cx="420276" cy="420276"/>
-          </a:xfrm>
-          <a:prstGeom prst="line">
-            <a:avLst/>
-          </a:prstGeom>
-          <a:ln w="30480">
-            <a:solidFill>
-              <a:srgbClr val="8EDBD4"/>
-            </a:solidFill>
-            <a:headEnd type="none" w="med" len="med"/>
-            <a:tailEnd type="triangle" w="med" len="med"/>
-          </a:ln>
-          <a:effectLst/>
-        </p:spPr>
-      </p:cxnSp>
-      <p:sp>
-        <p:nvSpPr>
-          <p:cNvPr id="18" name="C1-E13 text 16" descr="sci-ppt:o016"/>
-          <p:cNvSpPr txBox="1"/>
-          <p:nvPr/>
-        </p:nvSpPr>
-        <p:spPr>
-          <a:xfrm>
-            <a:off x="502920" y="5212080"/>
-            <a:ext cx="3931920" cy="433070"/>
-          </a:xfrm>
-          <a:prstGeom prst="rect">
-            <a:avLst/>
-          </a:prstGeom>
-          <a:noFill/>
-          <a:effectLst/>
-        </p:spPr>
-        <p:txBody>
-          <a:bodyPr wrap="none" lIns="18288" rIns="18288" tIns="18288" bIns="18288" anchor="t">
-            <a:spAutoFit/>
-          </a:bodyPr>
-          <a:lstStyle/>
-          <a:p>
-            <a:pPr algn="l">
-              <a:spcAft>
-                <a:spcPts val="0"/>
-              </a:spcAft>
-            </a:pPr>
-            <a:r>
-              <a:rPr sz="1250" b="0" i="0">
-                <a:solidFill>
-                  <a:srgbClr val="E7F0F3"/>
-                </a:solidFill>
-                <a:latin typeface="Arial"/>
-              </a:rPr>
-              <a:t>p∞ squeezes the liquid; the gas pushes back</a:t>
-            </a:r>
-          </a:p>
-          <a:p>
-            <a:pPr algn="l">
-              <a:spcAft>
-                <a:spcPts val="0"/>
-              </a:spcAft>
-            </a:pPr>
-            <a:r>
-              <a:rPr sz="1250" b="0" i="0">
-                <a:solidFill>
-                  <a:srgbClr val="E7F0F3"/>
-                </a:solidFill>
-                <a:latin typeface="Arial"/>
-              </a:rPr>
-              <a:t>only with pᵥ.   Δp_c = p∞ − pᵥ &gt; 0.</a:t>
-            </a:r>
-          </a:p>
-        </p:txBody>
-      </p:sp>
-      <p:cxnSp>
-        <p:nvCxnSpPr>
-          <p:cNvPr id="19" name="C1-E13 line 17" descr="sci-ppt:o017"/>
-          <p:cNvCxnSpPr/>
-          <p:nvPr/>
-        </p:nvCxnSpPr>
-        <p:spPr>
-          <a:xfrm>
-            <a:off x="5577840" y="4937760"/>
-            <a:ext cx="5943600" cy="0"/>
+          <a:xfrm>
+            <a:off x="7132320" y="3063239"/>
+            <a:ext cx="4572000" cy="0"/>
           </a:xfrm>
           <a:prstGeom prst="line">
             <a:avLst/>
@@ -3664,14 +3160,14 @@
       </p:cxnSp>
       <p:cxnSp>
         <p:nvCxnSpPr>
-          <p:cNvPr id="20" name="C1-E13 line 18" descr="sci-ppt:o018"/>
+          <p:cNvPr id="4" name="C1-E13 line 2" descr="sci-ppt:o002"/>
           <p:cNvCxnSpPr/>
           <p:nvPr/>
         </p:nvCxnSpPr>
         <p:spPr>
           <a:xfrm>
-            <a:off x="5577840" y="1371600"/>
-            <a:ext cx="0" cy="3566160"/>
+            <a:off x="7132320" y="1325880"/>
+            <a:ext cx="0" cy="1737359"/>
           </a:xfrm>
           <a:prstGeom prst="line">
             <a:avLst/>
@@ -3686,13 +3182,13 @@
       </p:cxnSp>
       <p:cxnSp>
         <p:nvCxnSpPr>
-          <p:cNvPr id="21" name="C1-E13 line 19" descr="sci-ppt:o019"/>
+          <p:cNvPr id="5" name="C1-E13 line 3" descr="sci-ppt:o003"/>
           <p:cNvCxnSpPr/>
           <p:nvPr/>
         </p:nvCxnSpPr>
         <p:spPr>
           <a:xfrm>
-            <a:off x="5577840" y="4937760"/>
+            <a:off x="7132320" y="3063239"/>
             <a:ext cx="0" cy="64008"/>
           </a:xfrm>
           <a:prstGeom prst="line">
@@ -3708,14 +3204,14 @@
       </p:cxnSp>
       <p:cxnSp>
         <p:nvCxnSpPr>
-          <p:cNvPr id="22" name="C1-E13 line 20" descr="sci-ppt:o020"/>
+          <p:cNvPr id="6" name="C1-E13 line 4" descr="sci-ppt:o004"/>
           <p:cNvCxnSpPr/>
           <p:nvPr/>
         </p:nvCxnSpPr>
         <p:spPr>
           <a:xfrm>
-            <a:off x="5577840" y="1371600"/>
-            <a:ext cx="0" cy="3566160"/>
+            <a:off x="7132320" y="1325880"/>
+            <a:ext cx="0" cy="1737359"/>
           </a:xfrm>
           <a:prstGeom prst="line">
             <a:avLst/>
@@ -3730,13 +3226,13 @@
       </p:cxnSp>
       <p:sp>
         <p:nvSpPr>
-          <p:cNvPr id="23" name="C1-E13 text 21" descr="sci-ppt:o021"/>
+          <p:cNvPr id="7" name="C1-E13 text 5" descr="sci-ppt:o005"/>
           <p:cNvSpPr txBox="1"/>
           <p:nvPr/>
         </p:nvSpPr>
         <p:spPr>
           <a:xfrm>
-            <a:off x="5120640" y="5020056"/>
+            <a:off x="6675120" y="3145535"/>
             <a:ext cx="914400" cy="208407"/>
           </a:xfrm>
           <a:prstGeom prst="rect">
@@ -3752,364 +3248,6 @@
           <a:lstStyle/>
           <a:p>
             <a:pPr algn="ctr">
-              <a:spcAft>
-                <a:spcPts val="0"/>
-              </a:spcAft>
-            </a:pPr>
-            <a:r>
-              <a:rPr sz="1050" b="0" i="0">
-                <a:solidFill>
-                  <a:srgbClr val="B4C7D2"/>
-                </a:solidFill>
-                <a:latin typeface="Arial"/>
-              </a:rPr>
-              <a:t>0</a:t>
-            </a:r>
-          </a:p>
-        </p:txBody>
-      </p:sp>
-      <p:cxnSp>
-        <p:nvCxnSpPr>
-          <p:cNvPr id="24" name="C1-E13 line 22" descr="sci-ppt:o022"/>
-          <p:cNvCxnSpPr/>
-          <p:nvPr/>
-        </p:nvCxnSpPr>
-        <p:spPr>
-          <a:xfrm>
-            <a:off x="7559039" y="4937760"/>
-            <a:ext cx="0" cy="64008"/>
-          </a:xfrm>
-          <a:prstGeom prst="line">
-            <a:avLst/>
-          </a:prstGeom>
-          <a:ln w="12700">
-            <a:solidFill>
-              <a:srgbClr val="B4C7D2"/>
-            </a:solidFill>
-          </a:ln>
-          <a:effectLst/>
-        </p:spPr>
-      </p:cxnSp>
-      <p:cxnSp>
-        <p:nvCxnSpPr>
-          <p:cNvPr id="25" name="C1-E13 line 23" descr="sci-ppt:o023"/>
-          <p:cNvCxnSpPr/>
-          <p:nvPr/>
-        </p:nvCxnSpPr>
-        <p:spPr>
-          <a:xfrm>
-            <a:off x="7559039" y="1371600"/>
-            <a:ext cx="0" cy="3566160"/>
-          </a:xfrm>
-          <a:prstGeom prst="line">
-            <a:avLst/>
-          </a:prstGeom>
-          <a:ln w="7620">
-            <a:solidFill>
-              <a:srgbClr val="2E4756"/>
-            </a:solidFill>
-          </a:ln>
-          <a:effectLst/>
-        </p:spPr>
-      </p:cxnSp>
-      <p:sp>
-        <p:nvSpPr>
-          <p:cNvPr id="26" name="C1-E13 text 24" descr="sci-ppt:o024"/>
-          <p:cNvSpPr txBox="1"/>
-          <p:nvPr/>
-        </p:nvSpPr>
-        <p:spPr>
-          <a:xfrm>
-            <a:off x="7101839" y="5020056"/>
-            <a:ext cx="914400" cy="208407"/>
-          </a:xfrm>
-          <a:prstGeom prst="rect">
-            <a:avLst/>
-          </a:prstGeom>
-          <a:noFill/>
-          <a:effectLst/>
-        </p:spPr>
-        <p:txBody>
-          <a:bodyPr wrap="none" lIns="18288" rIns="18288" tIns="18288" bIns="18288" anchor="t">
-            <a:spAutoFit/>
-          </a:bodyPr>
-          <a:lstStyle/>
-          <a:p>
-            <a:pPr algn="ctr">
-              <a:spcAft>
-                <a:spcPts val="0"/>
-              </a:spcAft>
-            </a:pPr>
-            <a:r>
-              <a:rPr sz="1050" b="0" i="0">
-                <a:solidFill>
-                  <a:srgbClr val="B4C7D2"/>
-                </a:solidFill>
-                <a:latin typeface="Arial"/>
-              </a:rPr>
-              <a:t>1</a:t>
-            </a:r>
-          </a:p>
-        </p:txBody>
-      </p:sp>
-      <p:cxnSp>
-        <p:nvCxnSpPr>
-          <p:cNvPr id="27" name="C1-E13 line 25" descr="sci-ppt:o025"/>
-          <p:cNvCxnSpPr/>
-          <p:nvPr/>
-        </p:nvCxnSpPr>
-        <p:spPr>
-          <a:xfrm>
-            <a:off x="9540240" y="4937760"/>
-            <a:ext cx="0" cy="64008"/>
-          </a:xfrm>
-          <a:prstGeom prst="line">
-            <a:avLst/>
-          </a:prstGeom>
-          <a:ln w="12700">
-            <a:solidFill>
-              <a:srgbClr val="B4C7D2"/>
-            </a:solidFill>
-          </a:ln>
-          <a:effectLst/>
-        </p:spPr>
-      </p:cxnSp>
-      <p:cxnSp>
-        <p:nvCxnSpPr>
-          <p:cNvPr id="28" name="C1-E13 line 26" descr="sci-ppt:o026"/>
-          <p:cNvCxnSpPr/>
-          <p:nvPr/>
-        </p:nvCxnSpPr>
-        <p:spPr>
-          <a:xfrm>
-            <a:off x="9540240" y="1371600"/>
-            <a:ext cx="0" cy="3566160"/>
-          </a:xfrm>
-          <a:prstGeom prst="line">
-            <a:avLst/>
-          </a:prstGeom>
-          <a:ln w="7620">
-            <a:solidFill>
-              <a:srgbClr val="2E4756"/>
-            </a:solidFill>
-          </a:ln>
-          <a:effectLst/>
-        </p:spPr>
-      </p:cxnSp>
-      <p:sp>
-        <p:nvSpPr>
-          <p:cNvPr id="29" name="C1-E13 text 27" descr="sci-ppt:o027"/>
-          <p:cNvSpPr txBox="1"/>
-          <p:nvPr/>
-        </p:nvSpPr>
-        <p:spPr>
-          <a:xfrm>
-            <a:off x="9083040" y="5020056"/>
-            <a:ext cx="914400" cy="208407"/>
-          </a:xfrm>
-          <a:prstGeom prst="rect">
-            <a:avLst/>
-          </a:prstGeom>
-          <a:noFill/>
-          <a:effectLst/>
-        </p:spPr>
-        <p:txBody>
-          <a:bodyPr wrap="none" lIns="18288" rIns="18288" tIns="18288" bIns="18288" anchor="t">
-            <a:spAutoFit/>
-          </a:bodyPr>
-          <a:lstStyle/>
-          <a:p>
-            <a:pPr algn="ctr">
-              <a:spcAft>
-                <a:spcPts val="0"/>
-              </a:spcAft>
-            </a:pPr>
-            <a:r>
-              <a:rPr sz="1050" b="0" i="0">
-                <a:solidFill>
-                  <a:srgbClr val="B4C7D2"/>
-                </a:solidFill>
-                <a:latin typeface="Arial"/>
-              </a:rPr>
-              <a:t>2</a:t>
-            </a:r>
-          </a:p>
-        </p:txBody>
-      </p:sp>
-      <p:cxnSp>
-        <p:nvCxnSpPr>
-          <p:cNvPr id="30" name="C1-E13 line 28" descr="sci-ppt:o028"/>
-          <p:cNvCxnSpPr/>
-          <p:nvPr/>
-        </p:nvCxnSpPr>
-        <p:spPr>
-          <a:xfrm>
-            <a:off x="11521440" y="4937760"/>
-            <a:ext cx="0" cy="64008"/>
-          </a:xfrm>
-          <a:prstGeom prst="line">
-            <a:avLst/>
-          </a:prstGeom>
-          <a:ln w="12700">
-            <a:solidFill>
-              <a:srgbClr val="B4C7D2"/>
-            </a:solidFill>
-          </a:ln>
-          <a:effectLst/>
-        </p:spPr>
-      </p:cxnSp>
-      <p:cxnSp>
-        <p:nvCxnSpPr>
-          <p:cNvPr id="31" name="C1-E13 line 29" descr="sci-ppt:o029"/>
-          <p:cNvCxnSpPr/>
-          <p:nvPr/>
-        </p:nvCxnSpPr>
-        <p:spPr>
-          <a:xfrm>
-            <a:off x="11521440" y="1371600"/>
-            <a:ext cx="0" cy="3566160"/>
-          </a:xfrm>
-          <a:prstGeom prst="line">
-            <a:avLst/>
-          </a:prstGeom>
-          <a:ln w="7620">
-            <a:solidFill>
-              <a:srgbClr val="2E4756"/>
-            </a:solidFill>
-          </a:ln>
-          <a:effectLst/>
-        </p:spPr>
-      </p:cxnSp>
-      <p:sp>
-        <p:nvSpPr>
-          <p:cNvPr id="32" name="C1-E13 text 30" descr="sci-ppt:o030"/>
-          <p:cNvSpPr txBox="1"/>
-          <p:nvPr/>
-        </p:nvSpPr>
-        <p:spPr>
-          <a:xfrm>
-            <a:off x="11064240" y="5020056"/>
-            <a:ext cx="914400" cy="208407"/>
-          </a:xfrm>
-          <a:prstGeom prst="rect">
-            <a:avLst/>
-          </a:prstGeom>
-          <a:noFill/>
-          <a:effectLst/>
-        </p:spPr>
-        <p:txBody>
-          <a:bodyPr wrap="none" lIns="18288" rIns="18288" tIns="18288" bIns="18288" anchor="t">
-            <a:spAutoFit/>
-          </a:bodyPr>
-          <a:lstStyle/>
-          <a:p>
-            <a:pPr algn="ctr">
-              <a:spcAft>
-                <a:spcPts val="0"/>
-              </a:spcAft>
-            </a:pPr>
-            <a:r>
-              <a:rPr sz="1050" b="0" i="0">
-                <a:solidFill>
-                  <a:srgbClr val="B4C7D2"/>
-                </a:solidFill>
-                <a:latin typeface="Arial"/>
-              </a:rPr>
-              <a:t>3</a:t>
-            </a:r>
-          </a:p>
-        </p:txBody>
-      </p:sp>
-      <p:cxnSp>
-        <p:nvCxnSpPr>
-          <p:cNvPr id="33" name="C1-E13 line 31" descr="sci-ppt:o031"/>
-          <p:cNvCxnSpPr/>
-          <p:nvPr/>
-        </p:nvCxnSpPr>
-        <p:spPr>
-          <a:xfrm>
-            <a:off x="5513831" y="4937760"/>
-            <a:ext cx="64009" cy="0"/>
-          </a:xfrm>
-          <a:prstGeom prst="line">
-            <a:avLst/>
-          </a:prstGeom>
-          <a:ln w="12700">
-            <a:solidFill>
-              <a:srgbClr val="B4C7D2"/>
-            </a:solidFill>
-          </a:ln>
-          <a:effectLst/>
-        </p:spPr>
-      </p:cxnSp>
-      <p:cxnSp>
-        <p:nvCxnSpPr>
-          <p:cNvPr id="34" name="C1-E13 line 32" descr="sci-ppt:o032"/>
-          <p:cNvCxnSpPr/>
-          <p:nvPr/>
-        </p:nvCxnSpPr>
-        <p:spPr>
-          <a:xfrm>
-            <a:off x="5513831" y="4088674"/>
-            <a:ext cx="64009" cy="0"/>
-          </a:xfrm>
-          <a:prstGeom prst="line">
-            <a:avLst/>
-          </a:prstGeom>
-          <a:ln w="12700">
-            <a:solidFill>
-              <a:srgbClr val="B4C7D2"/>
-            </a:solidFill>
-          </a:ln>
-          <a:effectLst/>
-        </p:spPr>
-      </p:cxnSp>
-      <p:cxnSp>
-        <p:nvCxnSpPr>
-          <p:cNvPr id="35" name="C1-E13 line 33" descr="sci-ppt:o033"/>
-          <p:cNvCxnSpPr/>
-          <p:nvPr/>
-        </p:nvCxnSpPr>
-        <p:spPr>
-          <a:xfrm>
-            <a:off x="5577840" y="4088674"/>
-            <a:ext cx="5943600" cy="0"/>
-          </a:xfrm>
-          <a:prstGeom prst="line">
-            <a:avLst/>
-          </a:prstGeom>
-          <a:ln w="7620">
-            <a:solidFill>
-              <a:srgbClr val="2E4756"/>
-            </a:solidFill>
-          </a:ln>
-          <a:effectLst/>
-        </p:spPr>
-      </p:cxnSp>
-      <p:sp>
-        <p:nvSpPr>
-          <p:cNvPr id="36" name="C1-E13 text 34" descr="sci-ppt:o034"/>
-          <p:cNvSpPr txBox="1"/>
-          <p:nvPr/>
-        </p:nvSpPr>
-        <p:spPr>
-          <a:xfrm>
-            <a:off x="4709159" y="4006378"/>
-            <a:ext cx="777240" cy="208407"/>
-          </a:xfrm>
-          <a:prstGeom prst="rect">
-            <a:avLst/>
-          </a:prstGeom>
-          <a:noFill/>
-          <a:effectLst/>
-        </p:spPr>
-        <p:txBody>
-          <a:bodyPr wrap="none" lIns="18288" rIns="18288" tIns="18288" bIns="18288" anchor="t">
-            <a:spAutoFit/>
-          </a:bodyPr>
-          <a:lstStyle/>
-          <a:p>
-            <a:pPr algn="r">
               <a:spcAft>
                 <a:spcPts val="0"/>
               </a:spcAft>
@@ -4128,14 +3266,14 @@
       </p:sp>
       <p:cxnSp>
         <p:nvCxnSpPr>
-          <p:cNvPr id="37" name="C1-E13 line 35" descr="sci-ppt:o035"/>
+          <p:cNvPr id="8" name="C1-E13 line 6" descr="sci-ppt:o006"/>
           <p:cNvCxnSpPr/>
           <p:nvPr/>
         </p:nvCxnSpPr>
         <p:spPr>
           <a:xfrm>
-            <a:off x="5513831" y="3239588"/>
-            <a:ext cx="64009" cy="0"/>
+            <a:off x="8656320" y="3063239"/>
+            <a:ext cx="0" cy="64008"/>
           </a:xfrm>
           <a:prstGeom prst="line">
             <a:avLst/>
@@ -4150,14 +3288,14 @@
       </p:cxnSp>
       <p:cxnSp>
         <p:nvCxnSpPr>
-          <p:cNvPr id="38" name="C1-E13 line 36" descr="sci-ppt:o036"/>
+          <p:cNvPr id="9" name="C1-E13 line 7" descr="sci-ppt:o007"/>
           <p:cNvCxnSpPr/>
           <p:nvPr/>
         </p:nvCxnSpPr>
         <p:spPr>
           <a:xfrm>
-            <a:off x="5577840" y="3239588"/>
-            <a:ext cx="5943600" cy="0"/>
+            <a:off x="8656320" y="1325880"/>
+            <a:ext cx="0" cy="1737359"/>
           </a:xfrm>
           <a:prstGeom prst="line">
             <a:avLst/>
@@ -4172,14 +3310,14 @@
       </p:cxnSp>
       <p:sp>
         <p:nvSpPr>
-          <p:cNvPr id="39" name="C1-E13 text 37" descr="sci-ppt:o037"/>
+          <p:cNvPr id="10" name="C1-E13 text 8" descr="sci-ppt:o008"/>
           <p:cNvSpPr txBox="1"/>
           <p:nvPr/>
         </p:nvSpPr>
         <p:spPr>
           <a:xfrm>
-            <a:off x="4709159" y="3157292"/>
-            <a:ext cx="777240" cy="208407"/>
+            <a:off x="8199120" y="3145535"/>
+            <a:ext cx="914400" cy="208407"/>
           </a:xfrm>
           <a:prstGeom prst="rect">
             <a:avLst/>
@@ -4193,7 +3331,7 @@
           </a:bodyPr>
           <a:lstStyle/>
           <a:p>
-            <a:pPr algn="r">
+            <a:pPr algn="ctr">
               <a:spcAft>
                 <a:spcPts val="0"/>
               </a:spcAft>
@@ -4212,14 +3350,14 @@
       </p:sp>
       <p:cxnSp>
         <p:nvCxnSpPr>
-          <p:cNvPr id="40" name="C1-E13 line 38" descr="sci-ppt:o038"/>
+          <p:cNvPr id="11" name="C1-E13 line 9" descr="sci-ppt:o009"/>
           <p:cNvCxnSpPr/>
           <p:nvPr/>
         </p:nvCxnSpPr>
         <p:spPr>
           <a:xfrm>
-            <a:off x="5513831" y="2390502"/>
-            <a:ext cx="64009" cy="0"/>
+            <a:off x="10180320" y="3063239"/>
+            <a:ext cx="0" cy="64008"/>
           </a:xfrm>
           <a:prstGeom prst="line">
             <a:avLst/>
@@ -4234,14 +3372,14 @@
       </p:cxnSp>
       <p:cxnSp>
         <p:nvCxnSpPr>
-          <p:cNvPr id="41" name="C1-E13 line 39" descr="sci-ppt:o039"/>
+          <p:cNvPr id="12" name="C1-E13 line 10" descr="sci-ppt:o010"/>
           <p:cNvCxnSpPr/>
           <p:nvPr/>
         </p:nvCxnSpPr>
         <p:spPr>
           <a:xfrm>
-            <a:off x="5577840" y="2390502"/>
-            <a:ext cx="5943600" cy="0"/>
+            <a:off x="10180320" y="1325880"/>
+            <a:ext cx="0" cy="1737359"/>
           </a:xfrm>
           <a:prstGeom prst="line">
             <a:avLst/>
@@ -4256,14 +3394,14 @@
       </p:cxnSp>
       <p:sp>
         <p:nvSpPr>
-          <p:cNvPr id="42" name="C1-E13 text 40" descr="sci-ppt:o040"/>
+          <p:cNvPr id="13" name="C1-E13 text 11" descr="sci-ppt:o011"/>
           <p:cNvSpPr txBox="1"/>
           <p:nvPr/>
         </p:nvSpPr>
         <p:spPr>
           <a:xfrm>
-            <a:off x="4709159" y="2308206"/>
-            <a:ext cx="777240" cy="208407"/>
+            <a:off x="9723120" y="3145535"/>
+            <a:ext cx="914400" cy="208407"/>
           </a:xfrm>
           <a:prstGeom prst="rect">
             <a:avLst/>
@@ -4277,7 +3415,7 @@
           </a:bodyPr>
           <a:lstStyle/>
           <a:p>
-            <a:pPr algn="r">
+            <a:pPr algn="ctr">
               <a:spcAft>
                 <a:spcPts val="0"/>
               </a:spcAft>
@@ -4296,14 +3434,14 @@
       </p:sp>
       <p:cxnSp>
         <p:nvCxnSpPr>
-          <p:cNvPr id="43" name="C1-E13 line 41" descr="sci-ppt:o041"/>
+          <p:cNvPr id="14" name="C1-E13 line 12" descr="sci-ppt:o012"/>
           <p:cNvCxnSpPr/>
           <p:nvPr/>
         </p:nvCxnSpPr>
         <p:spPr>
           <a:xfrm>
-            <a:off x="5513831" y="1541417"/>
-            <a:ext cx="64009" cy="0"/>
+            <a:off x="11704320" y="3063239"/>
+            <a:ext cx="0" cy="64008"/>
           </a:xfrm>
           <a:prstGeom prst="line">
             <a:avLst/>
@@ -4318,14 +3456,14 @@
       </p:cxnSp>
       <p:cxnSp>
         <p:nvCxnSpPr>
-          <p:cNvPr id="44" name="C1-E13 line 42" descr="sci-ppt:o042"/>
+          <p:cNvPr id="15" name="C1-E13 line 13" descr="sci-ppt:o013"/>
           <p:cNvCxnSpPr/>
           <p:nvPr/>
         </p:nvCxnSpPr>
         <p:spPr>
           <a:xfrm>
-            <a:off x="5577840" y="1541417"/>
-            <a:ext cx="5943600" cy="0"/>
+            <a:off x="11704320" y="1325880"/>
+            <a:ext cx="0" cy="1737359"/>
           </a:xfrm>
           <a:prstGeom prst="line">
             <a:avLst/>
@@ -4340,14 +3478,14 @@
       </p:cxnSp>
       <p:sp>
         <p:nvSpPr>
-          <p:cNvPr id="45" name="C1-E13 text 43" descr="sci-ppt:o043"/>
+          <p:cNvPr id="16" name="C1-E13 text 14" descr="sci-ppt:o014"/>
           <p:cNvSpPr txBox="1"/>
           <p:nvPr/>
         </p:nvSpPr>
         <p:spPr>
           <a:xfrm>
-            <a:off x="4709159" y="1459121"/>
-            <a:ext cx="777240" cy="208407"/>
+            <a:off x="11247120" y="3145535"/>
+            <a:ext cx="914400" cy="208407"/>
           </a:xfrm>
           <a:prstGeom prst="rect">
             <a:avLst/>
@@ -4361,7 +3499,7 @@
           </a:bodyPr>
           <a:lstStyle/>
           <a:p>
-            <a:pPr algn="r">
+            <a:pPr algn="ctr">
               <a:spcAft>
                 <a:spcPts val="0"/>
               </a:spcAft>
@@ -4378,16 +3516,82 @@
           </a:p>
         </p:txBody>
       </p:sp>
-      <p:sp>
-        <p:nvSpPr>
-          <p:cNvPr id="46" name="C1-E13 text 44" descr="sci-ppt:o044"/>
+      <p:cxnSp>
+        <p:nvCxnSpPr>
+          <p:cNvPr id="17" name="C1-E13 line 15" descr="sci-ppt:o015"/>
+          <p:cNvCxnSpPr/>
+          <p:nvPr/>
+        </p:nvCxnSpPr>
+        <p:spPr>
+          <a:xfrm>
+            <a:off x="7068312" y="3063239"/>
+            <a:ext cx="64008" cy="0"/>
+          </a:xfrm>
+          <a:prstGeom prst="line">
+            <a:avLst/>
+          </a:prstGeom>
+          <a:ln w="12700">
+            <a:solidFill>
+              <a:srgbClr val="B4C7D2"/>
+            </a:solidFill>
+          </a:ln>
+          <a:effectLst/>
+        </p:spPr>
+      </p:cxnSp>
+      <p:cxnSp>
+        <p:nvCxnSpPr>
+          <p:cNvPr id="18" name="C1-E13 line 16" descr="sci-ppt:o016"/>
+          <p:cNvCxnSpPr/>
+          <p:nvPr/>
+        </p:nvCxnSpPr>
+        <p:spPr>
+          <a:xfrm>
+            <a:off x="7068312" y="2520314"/>
+            <a:ext cx="64008" cy="0"/>
+          </a:xfrm>
+          <a:prstGeom prst="line">
+            <a:avLst/>
+          </a:prstGeom>
+          <a:ln w="12700">
+            <a:solidFill>
+              <a:srgbClr val="B4C7D2"/>
+            </a:solidFill>
+          </a:ln>
+          <a:effectLst/>
+        </p:spPr>
+      </p:cxnSp>
+      <p:cxnSp>
+        <p:nvCxnSpPr>
+          <p:cNvPr id="19" name="C1-E13 line 17" descr="sci-ppt:o017"/>
+          <p:cNvCxnSpPr/>
+          <p:nvPr/>
+        </p:nvCxnSpPr>
+        <p:spPr>
+          <a:xfrm>
+            <a:off x="7132320" y="2520314"/>
+            <a:ext cx="4572000" cy="0"/>
+          </a:xfrm>
+          <a:prstGeom prst="line">
+            <a:avLst/>
+          </a:prstGeom>
+          <a:ln w="7620">
+            <a:solidFill>
+              <a:srgbClr val="2E4756"/>
+            </a:solidFill>
+          </a:ln>
+          <a:effectLst/>
+        </p:spPr>
+      </p:cxnSp>
+      <p:sp>
+        <p:nvSpPr>
+          <p:cNvPr id="20" name="C1-E13 text 18" descr="sci-ppt:o018"/>
           <p:cNvSpPr txBox="1"/>
           <p:nvPr/>
         </p:nvSpPr>
         <p:spPr>
           <a:xfrm>
-            <a:off x="5577840" y="5221224"/>
-            <a:ext cx="5943600" cy="231648"/>
+            <a:off x="6263640" y="2438019"/>
+            <a:ext cx="777240" cy="208407"/>
           </a:xfrm>
           <a:prstGeom prst="rect">
             <a:avLst/>
@@ -4401,7 +3605,215 @@
           </a:bodyPr>
           <a:lstStyle/>
           <a:p>
-            <a:pPr algn="ctr">
+            <a:pPr algn="r">
+              <a:spcAft>
+                <a:spcPts val="0"/>
+              </a:spcAft>
+            </a:pPr>
+            <a:r>
+              <a:rPr sz="1050" b="0" i="0">
+                <a:solidFill>
+                  <a:srgbClr val="B4C7D2"/>
+                </a:solidFill>
+                <a:latin typeface="Arial"/>
+              </a:rPr>
+              <a:t>20</a:t>
+            </a:r>
+          </a:p>
+        </p:txBody>
+      </p:sp>
+      <p:cxnSp>
+        <p:nvCxnSpPr>
+          <p:cNvPr id="21" name="C1-E13 line 19" descr="sci-ppt:o019"/>
+          <p:cNvCxnSpPr/>
+          <p:nvPr/>
+        </p:nvCxnSpPr>
+        <p:spPr>
+          <a:xfrm>
+            <a:off x="7068312" y="1977389"/>
+            <a:ext cx="64008" cy="0"/>
+          </a:xfrm>
+          <a:prstGeom prst="line">
+            <a:avLst/>
+          </a:prstGeom>
+          <a:ln w="12700">
+            <a:solidFill>
+              <a:srgbClr val="B4C7D2"/>
+            </a:solidFill>
+          </a:ln>
+          <a:effectLst/>
+        </p:spPr>
+      </p:cxnSp>
+      <p:cxnSp>
+        <p:nvCxnSpPr>
+          <p:cNvPr id="22" name="C1-E13 line 20" descr="sci-ppt:o020"/>
+          <p:cNvCxnSpPr/>
+          <p:nvPr/>
+        </p:nvCxnSpPr>
+        <p:spPr>
+          <a:xfrm>
+            <a:off x="7132320" y="1977389"/>
+            <a:ext cx="4572000" cy="0"/>
+          </a:xfrm>
+          <a:prstGeom prst="line">
+            <a:avLst/>
+          </a:prstGeom>
+          <a:ln w="7620">
+            <a:solidFill>
+              <a:srgbClr val="2E4756"/>
+            </a:solidFill>
+          </a:ln>
+          <a:effectLst/>
+        </p:spPr>
+      </p:cxnSp>
+      <p:sp>
+        <p:nvSpPr>
+          <p:cNvPr id="23" name="C1-E13 text 21" descr="sci-ppt:o021"/>
+          <p:cNvSpPr txBox="1"/>
+          <p:nvPr/>
+        </p:nvSpPr>
+        <p:spPr>
+          <a:xfrm>
+            <a:off x="6263640" y="1895093"/>
+            <a:ext cx="777240" cy="208407"/>
+          </a:xfrm>
+          <a:prstGeom prst="rect">
+            <a:avLst/>
+          </a:prstGeom>
+          <a:noFill/>
+          <a:effectLst/>
+        </p:spPr>
+        <p:txBody>
+          <a:bodyPr wrap="none" lIns="18288" rIns="18288" tIns="18288" bIns="18288" anchor="t">
+            <a:spAutoFit/>
+          </a:bodyPr>
+          <a:lstStyle/>
+          <a:p>
+            <a:pPr algn="r">
+              <a:spcAft>
+                <a:spcPts val="0"/>
+              </a:spcAft>
+            </a:pPr>
+            <a:r>
+              <a:rPr sz="1050" b="0" i="0">
+                <a:solidFill>
+                  <a:srgbClr val="B4C7D2"/>
+                </a:solidFill>
+                <a:latin typeface="Arial"/>
+              </a:rPr>
+              <a:t>40</a:t>
+            </a:r>
+          </a:p>
+        </p:txBody>
+      </p:sp>
+      <p:cxnSp>
+        <p:nvCxnSpPr>
+          <p:cNvPr id="24" name="C1-E13 line 22" descr="sci-ppt:o022"/>
+          <p:cNvCxnSpPr/>
+          <p:nvPr/>
+        </p:nvCxnSpPr>
+        <p:spPr>
+          <a:xfrm>
+            <a:off x="7068312" y="1434464"/>
+            <a:ext cx="64008" cy="0"/>
+          </a:xfrm>
+          <a:prstGeom prst="line">
+            <a:avLst/>
+          </a:prstGeom>
+          <a:ln w="12700">
+            <a:solidFill>
+              <a:srgbClr val="B4C7D2"/>
+            </a:solidFill>
+          </a:ln>
+          <a:effectLst/>
+        </p:spPr>
+      </p:cxnSp>
+      <p:cxnSp>
+        <p:nvCxnSpPr>
+          <p:cNvPr id="25" name="C1-E13 line 23" descr="sci-ppt:o023"/>
+          <p:cNvCxnSpPr/>
+          <p:nvPr/>
+        </p:nvCxnSpPr>
+        <p:spPr>
+          <a:xfrm>
+            <a:off x="7132320" y="1434464"/>
+            <a:ext cx="4572000" cy="0"/>
+          </a:xfrm>
+          <a:prstGeom prst="line">
+            <a:avLst/>
+          </a:prstGeom>
+          <a:ln w="7620">
+            <a:solidFill>
+              <a:srgbClr val="2E4756"/>
+            </a:solidFill>
+          </a:ln>
+          <a:effectLst/>
+        </p:spPr>
+      </p:cxnSp>
+      <p:sp>
+        <p:nvSpPr>
+          <p:cNvPr id="26" name="C1-E13 text 24" descr="sci-ppt:o024"/>
+          <p:cNvSpPr txBox="1"/>
+          <p:nvPr/>
+        </p:nvSpPr>
+        <p:spPr>
+          <a:xfrm>
+            <a:off x="6263640" y="1352168"/>
+            <a:ext cx="777240" cy="208407"/>
+          </a:xfrm>
+          <a:prstGeom prst="rect">
+            <a:avLst/>
+          </a:prstGeom>
+          <a:noFill/>
+          <a:effectLst/>
+        </p:spPr>
+        <p:txBody>
+          <a:bodyPr wrap="none" lIns="18288" rIns="18288" tIns="18288" bIns="18288" anchor="t">
+            <a:spAutoFit/>
+          </a:bodyPr>
+          <a:lstStyle/>
+          <a:p>
+            <a:pPr algn="r">
+              <a:spcAft>
+                <a:spcPts val="0"/>
+              </a:spcAft>
+            </a:pPr>
+            <a:r>
+              <a:rPr sz="1050" b="0" i="0">
+                <a:solidFill>
+                  <a:srgbClr val="B4C7D2"/>
+                </a:solidFill>
+                <a:latin typeface="Arial"/>
+              </a:rPr>
+              <a:t>60</a:t>
+            </a:r>
+          </a:p>
+        </p:txBody>
+      </p:sp>
+      <p:sp>
+        <p:nvSpPr>
+          <p:cNvPr id="27" name="C1-E13 text 25" descr="sci-ppt:o025"/>
+          <p:cNvSpPr txBox="1"/>
+          <p:nvPr/>
+        </p:nvSpPr>
+        <p:spPr>
+          <a:xfrm>
+            <a:off x="6583680" y="978407"/>
+            <a:ext cx="4572000" cy="231648"/>
+          </a:xfrm>
+          <a:prstGeom prst="rect">
+            <a:avLst/>
+          </a:prstGeom>
+          <a:noFill/>
+          <a:effectLst/>
+        </p:spPr>
+        <p:txBody>
+          <a:bodyPr wrap="none" lIns="18288" rIns="18288" tIns="18288" bIns="18288" anchor="t">
+            <a:spAutoFit/>
+          </a:bodyPr>
+          <a:lstStyle/>
+          <a:p>
+            <a:pPr algn="l">
               <a:spcAft>
                 <a:spcPts val="0"/>
               </a:spcAft>
@@ -4413,21 +3825,512 @@
                 </a:solidFill>
                 <a:latin typeface="Arial"/>
               </a:rPr>
-              <a:t>t  (µs)</a:t>
-            </a:r>
-          </a:p>
-        </p:txBody>
-      </p:sp>
-      <p:sp>
-        <p:nvSpPr>
-          <p:cNvPr id="47" name="C1-E13 text 45" descr="sci-ppt:o045"/>
+              <a:t>y (scaled)</a:t>
+            </a:r>
+          </a:p>
+        </p:txBody>
+      </p:sp>
+      <p:sp>
+        <p:nvSpPr>
+          <p:cNvPr id="28" name="C1-E13 polygon 26" descr="sci-ppt:o026"/>
+          <p:cNvSpPr/>
+          <p:nvPr/>
+        </p:nvSpPr>
+        <p:spPr>
+          <a:xfrm>
+            <a:off x="7132320" y="1353026"/>
+            <a:ext cx="4572000" cy="1710213"/>
+          </a:xfrm>
+          <a:custGeom>
+            <a:avLst/>
+            <a:gdLst/>
+            <a:ahLst/>
+            <a:cxnLst/>
+            <a:rect l="l" t="t" r="r" b="b"/>
+            <a:pathLst>
+              <a:path w="4572000" h="1710213">
+                <a:moveTo>
+                  <a:pt x="0" y="0"/>
+                </a:moveTo>
+                <a:lnTo>
+                  <a:pt x="30581" y="100529"/>
+                </a:lnTo>
+                <a:lnTo>
+                  <a:pt x="61163" y="193449"/>
+                </a:lnTo>
+                <a:lnTo>
+                  <a:pt x="91745" y="279467"/>
+                </a:lnTo>
+                <a:lnTo>
+                  <a:pt x="122327" y="359212"/>
+                </a:lnTo>
+                <a:lnTo>
+                  <a:pt x="152909" y="433245"/>
+                </a:lnTo>
+                <a:lnTo>
+                  <a:pt x="183491" y="502070"/>
+                </a:lnTo>
+                <a:lnTo>
+                  <a:pt x="214073" y="566135"/>
+                </a:lnTo>
+                <a:lnTo>
+                  <a:pt x="244655" y="625846"/>
+                </a:lnTo>
+                <a:lnTo>
+                  <a:pt x="275237" y="681566"/>
+                </a:lnTo>
+                <a:lnTo>
+                  <a:pt x="305819" y="733623"/>
+                </a:lnTo>
+                <a:lnTo>
+                  <a:pt x="336401" y="782313"/>
+                </a:lnTo>
+                <a:lnTo>
+                  <a:pt x="366983" y="827904"/>
+                </a:lnTo>
+                <a:lnTo>
+                  <a:pt x="397565" y="870639"/>
+                </a:lnTo>
+                <a:lnTo>
+                  <a:pt x="428147" y="910738"/>
+                </a:lnTo>
+                <a:lnTo>
+                  <a:pt x="458729" y="948400"/>
+                </a:lnTo>
+                <a:lnTo>
+                  <a:pt x="489311" y="983810"/>
+                </a:lnTo>
+                <a:lnTo>
+                  <a:pt x="519892" y="1017131"/>
+                </a:lnTo>
+                <a:lnTo>
+                  <a:pt x="550474" y="1048517"/>
+                </a:lnTo>
+                <a:lnTo>
+                  <a:pt x="581056" y="1078105"/>
+                </a:lnTo>
+                <a:lnTo>
+                  <a:pt x="611638" y="1106023"/>
+                </a:lnTo>
+                <a:lnTo>
+                  <a:pt x="642220" y="1132386"/>
+                </a:lnTo>
+                <a:lnTo>
+                  <a:pt x="672802" y="1157302"/>
+                </a:lnTo>
+                <a:lnTo>
+                  <a:pt x="703384" y="1180868"/>
+                </a:lnTo>
+                <a:lnTo>
+                  <a:pt x="733966" y="1203174"/>
+                </a:lnTo>
+                <a:lnTo>
+                  <a:pt x="764548" y="1224304"/>
+                </a:lnTo>
+                <a:lnTo>
+                  <a:pt x="795130" y="1244334"/>
+                </a:lnTo>
+                <a:lnTo>
+                  <a:pt x="825712" y="1263335"/>
+                </a:lnTo>
+                <a:lnTo>
+                  <a:pt x="856294" y="1281372"/>
+                </a:lnTo>
+                <a:lnTo>
+                  <a:pt x="886876" y="1298506"/>
+                </a:lnTo>
+                <a:lnTo>
+                  <a:pt x="917458" y="1314792"/>
+                </a:lnTo>
+                <a:lnTo>
+                  <a:pt x="948040" y="1330281"/>
+                </a:lnTo>
+                <a:lnTo>
+                  <a:pt x="978622" y="1345023"/>
+                </a:lnTo>
+                <a:lnTo>
+                  <a:pt x="1009204" y="1359062"/>
+                </a:lnTo>
+                <a:lnTo>
+                  <a:pt x="1039785" y="1372438"/>
+                </a:lnTo>
+                <a:lnTo>
+                  <a:pt x="1070367" y="1385192"/>
+                </a:lnTo>
+                <a:lnTo>
+                  <a:pt x="1100949" y="1397358"/>
+                </a:lnTo>
+                <a:lnTo>
+                  <a:pt x="1131531" y="1408970"/>
+                </a:lnTo>
+                <a:lnTo>
+                  <a:pt x="1162113" y="1420059"/>
+                </a:lnTo>
+                <a:lnTo>
+                  <a:pt x="1192695" y="1430654"/>
+                </a:lnTo>
+                <a:lnTo>
+                  <a:pt x="1223277" y="1440783"/>
+                </a:lnTo>
+                <a:lnTo>
+                  <a:pt x="1253859" y="1450471"/>
+                </a:lnTo>
+                <a:lnTo>
+                  <a:pt x="1284441" y="1459741"/>
+                </a:lnTo>
+                <a:lnTo>
+                  <a:pt x="1315023" y="1468616"/>
+                </a:lnTo>
+                <a:lnTo>
+                  <a:pt x="1345605" y="1477117"/>
+                </a:lnTo>
+                <a:lnTo>
+                  <a:pt x="1376187" y="1485263"/>
+                </a:lnTo>
+                <a:lnTo>
+                  <a:pt x="1406769" y="1493073"/>
+                </a:lnTo>
+                <a:lnTo>
+                  <a:pt x="1437351" y="1500563"/>
+                </a:lnTo>
+                <a:lnTo>
+                  <a:pt x="1467933" y="1507751"/>
+                </a:lnTo>
+                <a:lnTo>
+                  <a:pt x="1498515" y="1514650"/>
+                </a:lnTo>
+                <a:lnTo>
+                  <a:pt x="1529096" y="1521276"/>
+                </a:lnTo>
+                <a:lnTo>
+                  <a:pt x="1559678" y="1527641"/>
+                </a:lnTo>
+                <a:lnTo>
+                  <a:pt x="1590260" y="1533759"/>
+                </a:lnTo>
+                <a:lnTo>
+                  <a:pt x="1620842" y="1539641"/>
+                </a:lnTo>
+                <a:lnTo>
+                  <a:pt x="1651424" y="1545299"/>
+                </a:lnTo>
+                <a:lnTo>
+                  <a:pt x="1682006" y="1550743"/>
+                </a:lnTo>
+                <a:lnTo>
+                  <a:pt x="1712588" y="1555983"/>
+                </a:lnTo>
+                <a:lnTo>
+                  <a:pt x="1743170" y="1561028"/>
+                </a:lnTo>
+                <a:lnTo>
+                  <a:pt x="1773752" y="1565889"/>
+                </a:lnTo>
+                <a:lnTo>
+                  <a:pt x="1804334" y="1570572"/>
+                </a:lnTo>
+                <a:lnTo>
+                  <a:pt x="1834916" y="1575086"/>
+                </a:lnTo>
+                <a:lnTo>
+                  <a:pt x="1865498" y="1579439"/>
+                </a:lnTo>
+                <a:lnTo>
+                  <a:pt x="1896080" y="1583638"/>
+                </a:lnTo>
+                <a:lnTo>
+                  <a:pt x="1926662" y="1587689"/>
+                </a:lnTo>
+                <a:lnTo>
+                  <a:pt x="1957244" y="1591599"/>
+                </a:lnTo>
+                <a:lnTo>
+                  <a:pt x="1987826" y="1595374"/>
+                </a:lnTo>
+                <a:lnTo>
+                  <a:pt x="2018408" y="1599019"/>
+                </a:lnTo>
+                <a:lnTo>
+                  <a:pt x="2048989" y="1602541"/>
+                </a:lnTo>
+                <a:lnTo>
+                  <a:pt x="2079571" y="1605945"/>
+                </a:lnTo>
+                <a:lnTo>
+                  <a:pt x="2110153" y="1609234"/>
+                </a:lnTo>
+                <a:lnTo>
+                  <a:pt x="2140735" y="1612415"/>
+                </a:lnTo>
+                <a:lnTo>
+                  <a:pt x="2171317" y="1615492"/>
+                </a:lnTo>
+                <a:lnTo>
+                  <a:pt x="2201899" y="1618468"/>
+                </a:lnTo>
+                <a:lnTo>
+                  <a:pt x="2232481" y="1621348"/>
+                </a:lnTo>
+                <a:lnTo>
+                  <a:pt x="2263063" y="1624136"/>
+                </a:lnTo>
+                <a:lnTo>
+                  <a:pt x="2293645" y="1626835"/>
+                </a:lnTo>
+                <a:lnTo>
+                  <a:pt x="2324227" y="1629450"/>
+                </a:lnTo>
+                <a:lnTo>
+                  <a:pt x="2354809" y="1631982"/>
+                </a:lnTo>
+                <a:lnTo>
+                  <a:pt x="2385391" y="1634436"/>
+                </a:lnTo>
+                <a:lnTo>
+                  <a:pt x="2415973" y="1636814"/>
+                </a:lnTo>
+                <a:lnTo>
+                  <a:pt x="2446555" y="1639119"/>
+                </a:lnTo>
+                <a:lnTo>
+                  <a:pt x="2477137" y="1641355"/>
+                </a:lnTo>
+                <a:lnTo>
+                  <a:pt x="2507719" y="1643523"/>
+                </a:lnTo>
+                <a:lnTo>
+                  <a:pt x="2538301" y="1645626"/>
+                </a:lnTo>
+                <a:lnTo>
+                  <a:pt x="2568882" y="1647667"/>
+                </a:lnTo>
+                <a:lnTo>
+                  <a:pt x="2599464" y="1649648"/>
+                </a:lnTo>
+                <a:lnTo>
+                  <a:pt x="2630046" y="1651571"/>
+                </a:lnTo>
+                <a:lnTo>
+                  <a:pt x="2660628" y="1653438"/>
+                </a:lnTo>
+                <a:lnTo>
+                  <a:pt x="2691210" y="1655251"/>
+                </a:lnTo>
+                <a:lnTo>
+                  <a:pt x="2721792" y="1657013"/>
+                </a:lnTo>
+                <a:lnTo>
+                  <a:pt x="2752374" y="1658724"/>
+                </a:lnTo>
+                <a:lnTo>
+                  <a:pt x="2782956" y="1660388"/>
+                </a:lnTo>
+                <a:lnTo>
+                  <a:pt x="2813538" y="1662004"/>
+                </a:lnTo>
+                <a:lnTo>
+                  <a:pt x="2844120" y="1663576"/>
+                </a:lnTo>
+                <a:lnTo>
+                  <a:pt x="2874702" y="1665104"/>
+                </a:lnTo>
+                <a:lnTo>
+                  <a:pt x="2905284" y="1666591"/>
+                </a:lnTo>
+                <a:lnTo>
+                  <a:pt x="2935866" y="1668036"/>
+                </a:lnTo>
+                <a:lnTo>
+                  <a:pt x="2966448" y="1669443"/>
+                </a:lnTo>
+                <a:lnTo>
+                  <a:pt x="2997030" y="1670812"/>
+                </a:lnTo>
+                <a:lnTo>
+                  <a:pt x="3027612" y="1672145"/>
+                </a:lnTo>
+                <a:lnTo>
+                  <a:pt x="3058193" y="1673442"/>
+                </a:lnTo>
+                <a:lnTo>
+                  <a:pt x="3088775" y="1674704"/>
+                </a:lnTo>
+                <a:lnTo>
+                  <a:pt x="3119357" y="1675934"/>
+                </a:lnTo>
+                <a:lnTo>
+                  <a:pt x="3149939" y="1677132"/>
+                </a:lnTo>
+                <a:lnTo>
+                  <a:pt x="3180521" y="1678299"/>
+                </a:lnTo>
+                <a:lnTo>
+                  <a:pt x="3211103" y="1679436"/>
+                </a:lnTo>
+                <a:lnTo>
+                  <a:pt x="3241685" y="1680544"/>
+                </a:lnTo>
+                <a:lnTo>
+                  <a:pt x="3272267" y="1681624"/>
+                </a:lnTo>
+                <a:lnTo>
+                  <a:pt x="3302849" y="1682677"/>
+                </a:lnTo>
+                <a:lnTo>
+                  <a:pt x="3333431" y="1683703"/>
+                </a:lnTo>
+                <a:lnTo>
+                  <a:pt x="3364013" y="1684704"/>
+                </a:lnTo>
+                <a:lnTo>
+                  <a:pt x="3394595" y="1685680"/>
+                </a:lnTo>
+                <a:lnTo>
+                  <a:pt x="3425177" y="1686632"/>
+                </a:lnTo>
+                <a:lnTo>
+                  <a:pt x="3455759" y="1687561"/>
+                </a:lnTo>
+                <a:lnTo>
+                  <a:pt x="3486341" y="1688467"/>
+                </a:lnTo>
+                <a:lnTo>
+                  <a:pt x="3516923" y="1689352"/>
+                </a:lnTo>
+                <a:lnTo>
+                  <a:pt x="3547505" y="1690215"/>
+                </a:lnTo>
+                <a:lnTo>
+                  <a:pt x="3578086" y="1691058"/>
+                </a:lnTo>
+                <a:lnTo>
+                  <a:pt x="3608668" y="1691880"/>
+                </a:lnTo>
+                <a:lnTo>
+                  <a:pt x="3639250" y="1692684"/>
+                </a:lnTo>
+                <a:lnTo>
+                  <a:pt x="3669832" y="1693468"/>
+                </a:lnTo>
+                <a:lnTo>
+                  <a:pt x="3700414" y="1694234"/>
+                </a:lnTo>
+                <a:lnTo>
+                  <a:pt x="3730996" y="1694983"/>
+                </a:lnTo>
+                <a:lnTo>
+                  <a:pt x="3761578" y="1695714"/>
+                </a:lnTo>
+                <a:lnTo>
+                  <a:pt x="3792160" y="1696429"/>
+                </a:lnTo>
+                <a:lnTo>
+                  <a:pt x="3822742" y="1697127"/>
+                </a:lnTo>
+                <a:lnTo>
+                  <a:pt x="3853324" y="1697810"/>
+                </a:lnTo>
+                <a:lnTo>
+                  <a:pt x="3883906" y="1698477"/>
+                </a:lnTo>
+                <a:lnTo>
+                  <a:pt x="3914488" y="1699129"/>
+                </a:lnTo>
+                <a:lnTo>
+                  <a:pt x="3945070" y="1699767"/>
+                </a:lnTo>
+                <a:lnTo>
+                  <a:pt x="3975652" y="1700391"/>
+                </a:lnTo>
+                <a:lnTo>
+                  <a:pt x="4006234" y="1701001"/>
+                </a:lnTo>
+                <a:lnTo>
+                  <a:pt x="4036816" y="1701597"/>
+                </a:lnTo>
+                <a:lnTo>
+                  <a:pt x="4067397" y="1702181"/>
+                </a:lnTo>
+                <a:lnTo>
+                  <a:pt x="4097979" y="1702752"/>
+                </a:lnTo>
+                <a:lnTo>
+                  <a:pt x="4128561" y="1703310"/>
+                </a:lnTo>
+                <a:lnTo>
+                  <a:pt x="4159143" y="1703857"/>
+                </a:lnTo>
+                <a:lnTo>
+                  <a:pt x="4189725" y="1704392"/>
+                </a:lnTo>
+                <a:lnTo>
+                  <a:pt x="4220307" y="1704916"/>
+                </a:lnTo>
+                <a:lnTo>
+                  <a:pt x="4250889" y="1705429"/>
+                </a:lnTo>
+                <a:lnTo>
+                  <a:pt x="4281471" y="1705931"/>
+                </a:lnTo>
+                <a:lnTo>
+                  <a:pt x="4312053" y="1706422"/>
+                </a:lnTo>
+                <a:lnTo>
+                  <a:pt x="4342635" y="1706903"/>
+                </a:lnTo>
+                <a:lnTo>
+                  <a:pt x="4373217" y="1707375"/>
+                </a:lnTo>
+                <a:lnTo>
+                  <a:pt x="4403799" y="1707836"/>
+                </a:lnTo>
+                <a:lnTo>
+                  <a:pt x="4434381" y="1708289"/>
+                </a:lnTo>
+                <a:lnTo>
+                  <a:pt x="4464963" y="1708732"/>
+                </a:lnTo>
+                <a:lnTo>
+                  <a:pt x="4495545" y="1709166"/>
+                </a:lnTo>
+                <a:lnTo>
+                  <a:pt x="4526127" y="1709591"/>
+                </a:lnTo>
+                <a:lnTo>
+                  <a:pt x="4556709" y="1710008"/>
+                </a:lnTo>
+                <a:lnTo>
+                  <a:pt x="4572000" y="1710213"/>
+                </a:lnTo>
+              </a:path>
+            </a:pathLst>
+          </a:custGeom>
+          <a:noFill/>
+          <a:ln w="38100">
+            <a:solidFill>
+              <a:srgbClr val="F28BA0"/>
+            </a:solidFill>
+          </a:ln>
+          <a:effectLst/>
+        </p:spPr>
+        <p:txBody>
+          <a:bodyPr rtlCol="0" anchor="ctr"/>
+          <a:lstStyle/>
+          <a:p>
+            <a:pPr algn="ctr"/>
+          </a:p>
+        </p:txBody>
+      </p:sp>
+      <p:sp>
+        <p:nvSpPr>
+          <p:cNvPr id="29" name="C1-E13 text 27" descr="sci-ppt:o027"/>
           <p:cNvSpPr txBox="1"/>
           <p:nvPr/>
         </p:nvSpPr>
         <p:spPr>
           <a:xfrm>
-            <a:off x="5029200" y="1024128"/>
-            <a:ext cx="5943600" cy="231648"/>
+            <a:off x="8729472" y="1478756"/>
+            <a:ext cx="3840480" cy="231648"/>
           </a:xfrm>
           <a:prstGeom prst="rect">
             <a:avLst/>
@@ -4442,6 +4345,700 @@
           <a:lstStyle/>
           <a:p>
             <a:pPr algn="l">
+              <a:spcAft>
+                <a:spcPts val="0"/>
+              </a:spcAft>
+            </a:pPr>
+            <a:r>
+              <a:rPr sz="1200" b="0" i="0">
+                <a:solidFill>
+                  <a:srgbClr val="F28BA0"/>
+                </a:solidFill>
+                <a:latin typeface="Arial"/>
+              </a:rPr>
+              <a:t>y = Ṙ² ∝ x⁻³ − 1: blows up inward</a:t>
+            </a:r>
+          </a:p>
+        </p:txBody>
+      </p:sp>
+      <p:cxnSp>
+        <p:nvCxnSpPr>
+          <p:cNvPr id="30" name="C1-E13 line 28" descr="sci-ppt:o028"/>
+          <p:cNvCxnSpPr/>
+          <p:nvPr/>
+        </p:nvCxnSpPr>
+        <p:spPr>
+          <a:xfrm>
+            <a:off x="7132320" y="5532120"/>
+            <a:ext cx="4572000" cy="0"/>
+          </a:xfrm>
+          <a:prstGeom prst="line">
+            <a:avLst/>
+          </a:prstGeom>
+          <a:ln w="19050">
+            <a:solidFill>
+              <a:srgbClr val="B4C7D2"/>
+            </a:solidFill>
+          </a:ln>
+          <a:effectLst/>
+        </p:spPr>
+      </p:cxnSp>
+      <p:cxnSp>
+        <p:nvCxnSpPr>
+          <p:cNvPr id="31" name="C1-E13 line 29" descr="sci-ppt:o029"/>
+          <p:cNvCxnSpPr/>
+          <p:nvPr/>
+        </p:nvCxnSpPr>
+        <p:spPr>
+          <a:xfrm>
+            <a:off x="7132320" y="3794760"/>
+            <a:ext cx="0" cy="1737360"/>
+          </a:xfrm>
+          <a:prstGeom prst="line">
+            <a:avLst/>
+          </a:prstGeom>
+          <a:ln w="19050">
+            <a:solidFill>
+              <a:srgbClr val="B4C7D2"/>
+            </a:solidFill>
+          </a:ln>
+          <a:effectLst/>
+        </p:spPr>
+      </p:cxnSp>
+      <p:cxnSp>
+        <p:nvCxnSpPr>
+          <p:cNvPr id="32" name="C1-E13 line 30" descr="sci-ppt:o030"/>
+          <p:cNvCxnSpPr/>
+          <p:nvPr/>
+        </p:nvCxnSpPr>
+        <p:spPr>
+          <a:xfrm>
+            <a:off x="7132320" y="5532120"/>
+            <a:ext cx="0" cy="64008"/>
+          </a:xfrm>
+          <a:prstGeom prst="line">
+            <a:avLst/>
+          </a:prstGeom>
+          <a:ln w="12700">
+            <a:solidFill>
+              <a:srgbClr val="B4C7D2"/>
+            </a:solidFill>
+          </a:ln>
+          <a:effectLst/>
+        </p:spPr>
+      </p:cxnSp>
+      <p:cxnSp>
+        <p:nvCxnSpPr>
+          <p:cNvPr id="33" name="C1-E13 line 31" descr="sci-ppt:o031"/>
+          <p:cNvCxnSpPr/>
+          <p:nvPr/>
+        </p:nvCxnSpPr>
+        <p:spPr>
+          <a:xfrm>
+            <a:off x="7132320" y="3794760"/>
+            <a:ext cx="0" cy="1737360"/>
+          </a:xfrm>
+          <a:prstGeom prst="line">
+            <a:avLst/>
+          </a:prstGeom>
+          <a:ln w="7620">
+            <a:solidFill>
+              <a:srgbClr val="2E4756"/>
+            </a:solidFill>
+          </a:ln>
+          <a:effectLst/>
+        </p:spPr>
+      </p:cxnSp>
+      <p:sp>
+        <p:nvSpPr>
+          <p:cNvPr id="34" name="C1-E13 text 32" descr="sci-ppt:o032"/>
+          <p:cNvSpPr txBox="1"/>
+          <p:nvPr/>
+        </p:nvSpPr>
+        <p:spPr>
+          <a:xfrm>
+            <a:off x="6675120" y="5614416"/>
+            <a:ext cx="914400" cy="208407"/>
+          </a:xfrm>
+          <a:prstGeom prst="rect">
+            <a:avLst/>
+          </a:prstGeom>
+          <a:noFill/>
+          <a:effectLst/>
+        </p:spPr>
+        <p:txBody>
+          <a:bodyPr wrap="none" lIns="18288" rIns="18288" tIns="18288" bIns="18288" anchor="t">
+            <a:spAutoFit/>
+          </a:bodyPr>
+          <a:lstStyle/>
+          <a:p>
+            <a:pPr algn="ctr">
+              <a:spcAft>
+                <a:spcPts val="0"/>
+              </a:spcAft>
+            </a:pPr>
+            <a:r>
+              <a:rPr sz="1050" b="0" i="0">
+                <a:solidFill>
+                  <a:srgbClr val="B4C7D2"/>
+                </a:solidFill>
+                <a:latin typeface="Arial"/>
+              </a:rPr>
+              <a:t>0.00</a:t>
+            </a:r>
+          </a:p>
+        </p:txBody>
+      </p:sp>
+      <p:cxnSp>
+        <p:nvCxnSpPr>
+          <p:cNvPr id="35" name="C1-E13 line 33" descr="sci-ppt:o033"/>
+          <p:cNvCxnSpPr/>
+          <p:nvPr/>
+        </p:nvCxnSpPr>
+        <p:spPr>
+          <a:xfrm>
+            <a:off x="8275320" y="5532120"/>
+            <a:ext cx="0" cy="64008"/>
+          </a:xfrm>
+          <a:prstGeom prst="line">
+            <a:avLst/>
+          </a:prstGeom>
+          <a:ln w="12700">
+            <a:solidFill>
+              <a:srgbClr val="B4C7D2"/>
+            </a:solidFill>
+          </a:ln>
+          <a:effectLst/>
+        </p:spPr>
+      </p:cxnSp>
+      <p:cxnSp>
+        <p:nvCxnSpPr>
+          <p:cNvPr id="36" name="C1-E13 line 34" descr="sci-ppt:o034"/>
+          <p:cNvCxnSpPr/>
+          <p:nvPr/>
+        </p:nvCxnSpPr>
+        <p:spPr>
+          <a:xfrm>
+            <a:off x="8275320" y="3794760"/>
+            <a:ext cx="0" cy="1737360"/>
+          </a:xfrm>
+          <a:prstGeom prst="line">
+            <a:avLst/>
+          </a:prstGeom>
+          <a:ln w="7620">
+            <a:solidFill>
+              <a:srgbClr val="2E4756"/>
+            </a:solidFill>
+          </a:ln>
+          <a:effectLst/>
+        </p:spPr>
+      </p:cxnSp>
+      <p:sp>
+        <p:nvSpPr>
+          <p:cNvPr id="37" name="C1-E13 text 35" descr="sci-ppt:o035"/>
+          <p:cNvSpPr txBox="1"/>
+          <p:nvPr/>
+        </p:nvSpPr>
+        <p:spPr>
+          <a:xfrm>
+            <a:off x="7818120" y="5614416"/>
+            <a:ext cx="914400" cy="208407"/>
+          </a:xfrm>
+          <a:prstGeom prst="rect">
+            <a:avLst/>
+          </a:prstGeom>
+          <a:noFill/>
+          <a:effectLst/>
+        </p:spPr>
+        <p:txBody>
+          <a:bodyPr wrap="none" lIns="18288" rIns="18288" tIns="18288" bIns="18288" anchor="t">
+            <a:spAutoFit/>
+          </a:bodyPr>
+          <a:lstStyle/>
+          <a:p>
+            <a:pPr algn="ctr">
+              <a:spcAft>
+                <a:spcPts val="0"/>
+              </a:spcAft>
+            </a:pPr>
+            <a:r>
+              <a:rPr sz="1050" b="0" i="0">
+                <a:solidFill>
+                  <a:srgbClr val="B4C7D2"/>
+                </a:solidFill>
+                <a:latin typeface="Arial"/>
+              </a:rPr>
+              <a:t>0.25</a:t>
+            </a:r>
+          </a:p>
+        </p:txBody>
+      </p:sp>
+      <p:cxnSp>
+        <p:nvCxnSpPr>
+          <p:cNvPr id="38" name="C1-E13 line 36" descr="sci-ppt:o036"/>
+          <p:cNvCxnSpPr/>
+          <p:nvPr/>
+        </p:nvCxnSpPr>
+        <p:spPr>
+          <a:xfrm>
+            <a:off x="9418320" y="5532120"/>
+            <a:ext cx="0" cy="64008"/>
+          </a:xfrm>
+          <a:prstGeom prst="line">
+            <a:avLst/>
+          </a:prstGeom>
+          <a:ln w="12700">
+            <a:solidFill>
+              <a:srgbClr val="B4C7D2"/>
+            </a:solidFill>
+          </a:ln>
+          <a:effectLst/>
+        </p:spPr>
+      </p:cxnSp>
+      <p:cxnSp>
+        <p:nvCxnSpPr>
+          <p:cNvPr id="39" name="C1-E13 line 37" descr="sci-ppt:o037"/>
+          <p:cNvCxnSpPr/>
+          <p:nvPr/>
+        </p:nvCxnSpPr>
+        <p:spPr>
+          <a:xfrm>
+            <a:off x="9418320" y="3794760"/>
+            <a:ext cx="0" cy="1737360"/>
+          </a:xfrm>
+          <a:prstGeom prst="line">
+            <a:avLst/>
+          </a:prstGeom>
+          <a:ln w="7620">
+            <a:solidFill>
+              <a:srgbClr val="2E4756"/>
+            </a:solidFill>
+          </a:ln>
+          <a:effectLst/>
+        </p:spPr>
+      </p:cxnSp>
+      <p:sp>
+        <p:nvSpPr>
+          <p:cNvPr id="40" name="C1-E13 text 38" descr="sci-ppt:o038"/>
+          <p:cNvSpPr txBox="1"/>
+          <p:nvPr/>
+        </p:nvSpPr>
+        <p:spPr>
+          <a:xfrm>
+            <a:off x="8961120" y="5614416"/>
+            <a:ext cx="914400" cy="208407"/>
+          </a:xfrm>
+          <a:prstGeom prst="rect">
+            <a:avLst/>
+          </a:prstGeom>
+          <a:noFill/>
+          <a:effectLst/>
+        </p:spPr>
+        <p:txBody>
+          <a:bodyPr wrap="none" lIns="18288" rIns="18288" tIns="18288" bIns="18288" anchor="t">
+            <a:spAutoFit/>
+          </a:bodyPr>
+          <a:lstStyle/>
+          <a:p>
+            <a:pPr algn="ctr">
+              <a:spcAft>
+                <a:spcPts val="0"/>
+              </a:spcAft>
+            </a:pPr>
+            <a:r>
+              <a:rPr sz="1050" b="0" i="0">
+                <a:solidFill>
+                  <a:srgbClr val="B4C7D2"/>
+                </a:solidFill>
+                <a:latin typeface="Arial"/>
+              </a:rPr>
+              <a:t>0.50</a:t>
+            </a:r>
+          </a:p>
+        </p:txBody>
+      </p:sp>
+      <p:cxnSp>
+        <p:nvCxnSpPr>
+          <p:cNvPr id="41" name="C1-E13 line 39" descr="sci-ppt:o039"/>
+          <p:cNvCxnSpPr/>
+          <p:nvPr/>
+        </p:nvCxnSpPr>
+        <p:spPr>
+          <a:xfrm>
+            <a:off x="10561320" y="5532120"/>
+            <a:ext cx="0" cy="64008"/>
+          </a:xfrm>
+          <a:prstGeom prst="line">
+            <a:avLst/>
+          </a:prstGeom>
+          <a:ln w="12700">
+            <a:solidFill>
+              <a:srgbClr val="B4C7D2"/>
+            </a:solidFill>
+          </a:ln>
+          <a:effectLst/>
+        </p:spPr>
+      </p:cxnSp>
+      <p:cxnSp>
+        <p:nvCxnSpPr>
+          <p:cNvPr id="42" name="C1-E13 line 40" descr="sci-ppt:o040"/>
+          <p:cNvCxnSpPr/>
+          <p:nvPr/>
+        </p:nvCxnSpPr>
+        <p:spPr>
+          <a:xfrm>
+            <a:off x="10561320" y="3794760"/>
+            <a:ext cx="0" cy="1737360"/>
+          </a:xfrm>
+          <a:prstGeom prst="line">
+            <a:avLst/>
+          </a:prstGeom>
+          <a:ln w="7620">
+            <a:solidFill>
+              <a:srgbClr val="2E4756"/>
+            </a:solidFill>
+          </a:ln>
+          <a:effectLst/>
+        </p:spPr>
+      </p:cxnSp>
+      <p:sp>
+        <p:nvSpPr>
+          <p:cNvPr id="43" name="C1-E13 text 41" descr="sci-ppt:o041"/>
+          <p:cNvSpPr txBox="1"/>
+          <p:nvPr/>
+        </p:nvSpPr>
+        <p:spPr>
+          <a:xfrm>
+            <a:off x="10104120" y="5614416"/>
+            <a:ext cx="914400" cy="208407"/>
+          </a:xfrm>
+          <a:prstGeom prst="rect">
+            <a:avLst/>
+          </a:prstGeom>
+          <a:noFill/>
+          <a:effectLst/>
+        </p:spPr>
+        <p:txBody>
+          <a:bodyPr wrap="none" lIns="18288" rIns="18288" tIns="18288" bIns="18288" anchor="t">
+            <a:spAutoFit/>
+          </a:bodyPr>
+          <a:lstStyle/>
+          <a:p>
+            <a:pPr algn="ctr">
+              <a:spcAft>
+                <a:spcPts val="0"/>
+              </a:spcAft>
+            </a:pPr>
+            <a:r>
+              <a:rPr sz="1050" b="0" i="0">
+                <a:solidFill>
+                  <a:srgbClr val="B4C7D2"/>
+                </a:solidFill>
+                <a:latin typeface="Arial"/>
+              </a:rPr>
+              <a:t>0.75</a:t>
+            </a:r>
+          </a:p>
+        </p:txBody>
+      </p:sp>
+      <p:cxnSp>
+        <p:nvCxnSpPr>
+          <p:cNvPr id="44" name="C1-E13 line 42" descr="sci-ppt:o042"/>
+          <p:cNvCxnSpPr/>
+          <p:nvPr/>
+        </p:nvCxnSpPr>
+        <p:spPr>
+          <a:xfrm>
+            <a:off x="11704320" y="5532120"/>
+            <a:ext cx="0" cy="64008"/>
+          </a:xfrm>
+          <a:prstGeom prst="line">
+            <a:avLst/>
+          </a:prstGeom>
+          <a:ln w="12700">
+            <a:solidFill>
+              <a:srgbClr val="B4C7D2"/>
+            </a:solidFill>
+          </a:ln>
+          <a:effectLst/>
+        </p:spPr>
+      </p:cxnSp>
+      <p:cxnSp>
+        <p:nvCxnSpPr>
+          <p:cNvPr id="45" name="C1-E13 line 43" descr="sci-ppt:o043"/>
+          <p:cNvCxnSpPr/>
+          <p:nvPr/>
+        </p:nvCxnSpPr>
+        <p:spPr>
+          <a:xfrm>
+            <a:off x="11704320" y="3794760"/>
+            <a:ext cx="0" cy="1737360"/>
+          </a:xfrm>
+          <a:prstGeom prst="line">
+            <a:avLst/>
+          </a:prstGeom>
+          <a:ln w="7620">
+            <a:solidFill>
+              <a:srgbClr val="2E4756"/>
+            </a:solidFill>
+          </a:ln>
+          <a:effectLst/>
+        </p:spPr>
+      </p:cxnSp>
+      <p:sp>
+        <p:nvSpPr>
+          <p:cNvPr id="46" name="C1-E13 text 44" descr="sci-ppt:o044"/>
+          <p:cNvSpPr txBox="1"/>
+          <p:nvPr/>
+        </p:nvSpPr>
+        <p:spPr>
+          <a:xfrm>
+            <a:off x="11247120" y="5614416"/>
+            <a:ext cx="914400" cy="208407"/>
+          </a:xfrm>
+          <a:prstGeom prst="rect">
+            <a:avLst/>
+          </a:prstGeom>
+          <a:noFill/>
+          <a:effectLst/>
+        </p:spPr>
+        <p:txBody>
+          <a:bodyPr wrap="none" lIns="18288" rIns="18288" tIns="18288" bIns="18288" anchor="t">
+            <a:spAutoFit/>
+          </a:bodyPr>
+          <a:lstStyle/>
+          <a:p>
+            <a:pPr algn="ctr">
+              <a:spcAft>
+                <a:spcPts val="0"/>
+              </a:spcAft>
+            </a:pPr>
+            <a:r>
+              <a:rPr sz="1050" b="0" i="0">
+                <a:solidFill>
+                  <a:srgbClr val="B4C7D2"/>
+                </a:solidFill>
+                <a:latin typeface="Arial"/>
+              </a:rPr>
+              <a:t>1.00</a:t>
+            </a:r>
+          </a:p>
+        </p:txBody>
+      </p:sp>
+      <p:cxnSp>
+        <p:nvCxnSpPr>
+          <p:cNvPr id="47" name="C1-E13 line 45" descr="sci-ppt:o045"/>
+          <p:cNvCxnSpPr/>
+          <p:nvPr/>
+        </p:nvCxnSpPr>
+        <p:spPr>
+          <a:xfrm>
+            <a:off x="7068312" y="5532120"/>
+            <a:ext cx="64008" cy="0"/>
+          </a:xfrm>
+          <a:prstGeom prst="line">
+            <a:avLst/>
+          </a:prstGeom>
+          <a:ln w="12700">
+            <a:solidFill>
+              <a:srgbClr val="B4C7D2"/>
+            </a:solidFill>
+          </a:ln>
+          <a:effectLst/>
+        </p:spPr>
+      </p:cxnSp>
+      <p:cxnSp>
+        <p:nvCxnSpPr>
+          <p:cNvPr id="48" name="C1-E13 line 46" descr="sci-ppt:o046"/>
+          <p:cNvCxnSpPr/>
+          <p:nvPr/>
+        </p:nvCxnSpPr>
+        <p:spPr>
+          <a:xfrm>
+            <a:off x="7068312" y="4742410"/>
+            <a:ext cx="64008" cy="0"/>
+          </a:xfrm>
+          <a:prstGeom prst="line">
+            <a:avLst/>
+          </a:prstGeom>
+          <a:ln w="12700">
+            <a:solidFill>
+              <a:srgbClr val="B4C7D2"/>
+            </a:solidFill>
+          </a:ln>
+          <a:effectLst/>
+        </p:spPr>
+      </p:cxnSp>
+      <p:cxnSp>
+        <p:nvCxnSpPr>
+          <p:cNvPr id="49" name="C1-E13 line 47" descr="sci-ppt:o047"/>
+          <p:cNvCxnSpPr/>
+          <p:nvPr/>
+        </p:nvCxnSpPr>
+        <p:spPr>
+          <a:xfrm>
+            <a:off x="7132320" y="4742410"/>
+            <a:ext cx="4572000" cy="0"/>
+          </a:xfrm>
+          <a:prstGeom prst="line">
+            <a:avLst/>
+          </a:prstGeom>
+          <a:ln w="7620">
+            <a:solidFill>
+              <a:srgbClr val="2E4756"/>
+            </a:solidFill>
+          </a:ln>
+          <a:effectLst/>
+        </p:spPr>
+      </p:cxnSp>
+      <p:sp>
+        <p:nvSpPr>
+          <p:cNvPr id="50" name="C1-E13 text 48" descr="sci-ppt:o048"/>
+          <p:cNvSpPr txBox="1"/>
+          <p:nvPr/>
+        </p:nvSpPr>
+        <p:spPr>
+          <a:xfrm>
+            <a:off x="6263640" y="4660114"/>
+            <a:ext cx="777240" cy="208407"/>
+          </a:xfrm>
+          <a:prstGeom prst="rect">
+            <a:avLst/>
+          </a:prstGeom>
+          <a:noFill/>
+          <a:effectLst/>
+        </p:spPr>
+        <p:txBody>
+          <a:bodyPr wrap="none" lIns="18288" rIns="18288" tIns="18288" bIns="18288" anchor="t">
+            <a:spAutoFit/>
+          </a:bodyPr>
+          <a:lstStyle/>
+          <a:p>
+            <a:pPr algn="r">
+              <a:spcAft>
+                <a:spcPts val="0"/>
+              </a:spcAft>
+            </a:pPr>
+            <a:r>
+              <a:rPr sz="1050" b="0" i="0">
+                <a:solidFill>
+                  <a:srgbClr val="B4C7D2"/>
+                </a:solidFill>
+                <a:latin typeface="Arial"/>
+              </a:rPr>
+              <a:t>0.5</a:t>
+            </a:r>
+          </a:p>
+        </p:txBody>
+      </p:sp>
+      <p:cxnSp>
+        <p:nvCxnSpPr>
+          <p:cNvPr id="51" name="C1-E13 line 49" descr="sci-ppt:o049"/>
+          <p:cNvCxnSpPr/>
+          <p:nvPr/>
+        </p:nvCxnSpPr>
+        <p:spPr>
+          <a:xfrm>
+            <a:off x="7068312" y="3952701"/>
+            <a:ext cx="64008" cy="0"/>
+          </a:xfrm>
+          <a:prstGeom prst="line">
+            <a:avLst/>
+          </a:prstGeom>
+          <a:ln w="12700">
+            <a:solidFill>
+              <a:srgbClr val="B4C7D2"/>
+            </a:solidFill>
+          </a:ln>
+          <a:effectLst/>
+        </p:spPr>
+      </p:cxnSp>
+      <p:cxnSp>
+        <p:nvCxnSpPr>
+          <p:cNvPr id="52" name="C1-E13 line 50" descr="sci-ppt:o050"/>
+          <p:cNvCxnSpPr/>
+          <p:nvPr/>
+        </p:nvCxnSpPr>
+        <p:spPr>
+          <a:xfrm>
+            <a:off x="7132320" y="3952701"/>
+            <a:ext cx="4572000" cy="0"/>
+          </a:xfrm>
+          <a:prstGeom prst="line">
+            <a:avLst/>
+          </a:prstGeom>
+          <a:ln w="7620">
+            <a:solidFill>
+              <a:srgbClr val="2E4756"/>
+            </a:solidFill>
+          </a:ln>
+          <a:effectLst/>
+        </p:spPr>
+      </p:cxnSp>
+      <p:sp>
+        <p:nvSpPr>
+          <p:cNvPr id="53" name="C1-E13 text 51" descr="sci-ppt:o051"/>
+          <p:cNvSpPr txBox="1"/>
+          <p:nvPr/>
+        </p:nvSpPr>
+        <p:spPr>
+          <a:xfrm>
+            <a:off x="6263640" y="3870405"/>
+            <a:ext cx="777240" cy="208407"/>
+          </a:xfrm>
+          <a:prstGeom prst="rect">
+            <a:avLst/>
+          </a:prstGeom>
+          <a:noFill/>
+          <a:effectLst/>
+        </p:spPr>
+        <p:txBody>
+          <a:bodyPr wrap="none" lIns="18288" rIns="18288" tIns="18288" bIns="18288" anchor="t">
+            <a:spAutoFit/>
+          </a:bodyPr>
+          <a:lstStyle/>
+          <a:p>
+            <a:pPr algn="r">
+              <a:spcAft>
+                <a:spcPts val="0"/>
+              </a:spcAft>
+            </a:pPr>
+            <a:r>
+              <a:rPr sz="1050" b="0" i="0">
+                <a:solidFill>
+                  <a:srgbClr val="B4C7D2"/>
+                </a:solidFill>
+                <a:latin typeface="Arial"/>
+              </a:rPr>
+              <a:t>1.0</a:t>
+            </a:r>
+          </a:p>
+        </p:txBody>
+      </p:sp>
+      <p:sp>
+        <p:nvSpPr>
+          <p:cNvPr id="54" name="C1-E13 text 52" descr="sci-ppt:o052"/>
+          <p:cNvSpPr txBox="1"/>
+          <p:nvPr/>
+        </p:nvSpPr>
+        <p:spPr>
+          <a:xfrm>
+            <a:off x="7132320" y="5815584"/>
+            <a:ext cx="4572000" cy="231648"/>
+          </a:xfrm>
+          <a:prstGeom prst="rect">
+            <a:avLst/>
+          </a:prstGeom>
+          <a:noFill/>
+          <a:effectLst/>
+        </p:spPr>
+        <p:txBody>
+          <a:bodyPr wrap="none" lIns="18288" rIns="18288" tIns="18288" bIns="18288" anchor="t">
+            <a:spAutoFit/>
+          </a:bodyPr>
+          <a:lstStyle/>
+          <a:p>
+            <a:pPr algn="ctr">
               <a:spcAft>
                 <a:spcPts val="0"/>
               </a:spcAft>
@@ -4453,21 +5050,61 @@
                 </a:solidFill>
                 <a:latin typeface="Arial"/>
               </a:rPr>
-              <a:t>R / Rₘₐₓ</a:t>
-            </a:r>
-          </a:p>
-        </p:txBody>
-      </p:sp>
-      <p:sp>
-        <p:nvSpPr>
-          <p:cNvPr id="48" name="C1-E13 polygon 46" descr="sci-ppt:o046"/>
+              <a:t>x = R / Rₘₐₓ</a:t>
+            </a:r>
+          </a:p>
+        </p:txBody>
+      </p:sp>
+      <p:sp>
+        <p:nvSpPr>
+          <p:cNvPr id="55" name="C1-E13 text 53" descr="sci-ppt:o053"/>
+          <p:cNvSpPr txBox="1"/>
+          <p:nvPr/>
+        </p:nvSpPr>
+        <p:spPr>
+          <a:xfrm>
+            <a:off x="6583680" y="3447288"/>
+            <a:ext cx="4572000" cy="231648"/>
+          </a:xfrm>
+          <a:prstGeom prst="rect">
+            <a:avLst/>
+          </a:prstGeom>
+          <a:noFill/>
+          <a:effectLst/>
+        </p:spPr>
+        <p:txBody>
+          <a:bodyPr wrap="none" lIns="18288" rIns="18288" tIns="18288" bIns="18288" anchor="t">
+            <a:spAutoFit/>
+          </a:bodyPr>
+          <a:lstStyle/>
+          <a:p>
+            <a:pPr algn="l">
+              <a:spcAft>
+                <a:spcPts val="0"/>
+              </a:spcAft>
+            </a:pPr>
+            <a:r>
+              <a:rPr sz="1200" b="0" i="0">
+                <a:solidFill>
+                  <a:srgbClr val="E7F0F3"/>
+                </a:solidFill>
+                <a:latin typeface="Arial"/>
+              </a:rPr>
+              <a:t>R³y (scaled)</a:t>
+            </a:r>
+          </a:p>
+        </p:txBody>
+      </p:sp>
+      <p:sp>
+        <p:nvSpPr>
+          <p:cNvPr id="56" name="C1-E13 polygon 54" descr="sci-ppt:o054"/>
           <p:cNvSpPr/>
           <p:nvPr/>
         </p:nvSpPr>
         <p:spPr>
           <a:xfrm>
-            <a:off x="5577840" y="1541417"/>
-            <a:ext cx="5436499" cy="3395663"/>
+            <a:off x="7132320" y="3952701"/>
+            <a:ext cx="4572000" cy="1579419"/>
           </a:xfrm>
           <a:custGeom>
             <a:avLst/>
@@ -4476,459 +5113,606 @@
             <a:cxnLst/>
             <a:rect l="l" t="t" r="r" b="b"/>
             <a:pathLst>
-              <a:path w="5436499" h="3395663">
+              <a:path w="4572000" h="1579419">
                 <a:moveTo>
                   <a:pt x="0" y="0"/>
                 </a:moveTo>
                 <a:lnTo>
-                  <a:pt x="56123" y="151"/>
-                </a:lnTo>
-                <a:lnTo>
-                  <a:pt x="112242" y="605"/>
-                </a:lnTo>
-                <a:lnTo>
-                  <a:pt x="168351" y="1362"/>
-                </a:lnTo>
-                <a:lnTo>
-                  <a:pt x="224445" y="2422"/>
-                </a:lnTo>
-                <a:lnTo>
-                  <a:pt x="280519" y="3785"/>
-                </a:lnTo>
-                <a:lnTo>
-                  <a:pt x="336568" y="5451"/>
-                </a:lnTo>
-                <a:lnTo>
-                  <a:pt x="392586" y="7419"/>
-                </a:lnTo>
-                <a:lnTo>
-                  <a:pt x="448570" y="9691"/>
-                </a:lnTo>
-                <a:lnTo>
-                  <a:pt x="504514" y="12265"/>
-                </a:lnTo>
-                <a:lnTo>
-                  <a:pt x="560412" y="15142"/>
-                </a:lnTo>
-                <a:lnTo>
-                  <a:pt x="616261" y="18322"/>
-                </a:lnTo>
-                <a:lnTo>
-                  <a:pt x="672054" y="21805"/>
-                </a:lnTo>
-                <a:lnTo>
-                  <a:pt x="727787" y="25590"/>
-                </a:lnTo>
-                <a:lnTo>
-                  <a:pt x="783455" y="29678"/>
-                </a:lnTo>
-                <a:lnTo>
-                  <a:pt x="839052" y="34070"/>
-                </a:lnTo>
-                <a:lnTo>
-                  <a:pt x="894575" y="38764"/>
-                </a:lnTo>
-                <a:lnTo>
-                  <a:pt x="950016" y="43761"/>
-                </a:lnTo>
-                <a:lnTo>
-                  <a:pt x="1005373" y="49061"/>
-                </a:lnTo>
-                <a:lnTo>
-                  <a:pt x="1060639" y="54663"/>
-                </a:lnTo>
-                <a:lnTo>
-                  <a:pt x="1115809" y="60569"/>
-                </a:lnTo>
-                <a:lnTo>
-                  <a:pt x="1170879" y="66777"/>
-                </a:lnTo>
-                <a:lnTo>
-                  <a:pt x="1225843" y="73288"/>
-                </a:lnTo>
-                <a:lnTo>
-                  <a:pt x="1280696" y="80102"/>
-                </a:lnTo>
-                <a:lnTo>
-                  <a:pt x="1335432" y="87219"/>
-                </a:lnTo>
-                <a:lnTo>
-                  <a:pt x="1390048" y="94639"/>
-                </a:lnTo>
-                <a:lnTo>
-                  <a:pt x="1444538" y="102361"/>
-                </a:lnTo>
-                <a:lnTo>
-                  <a:pt x="1498896" y="110387"/>
-                </a:lnTo>
-                <a:lnTo>
-                  <a:pt x="1553117" y="118715"/>
-                </a:lnTo>
-                <a:lnTo>
-                  <a:pt x="1607197" y="127346"/>
-                </a:lnTo>
-                <a:lnTo>
-                  <a:pt x="1661130" y="136280"/>
-                </a:lnTo>
-                <a:lnTo>
-                  <a:pt x="1714911" y="145517"/>
-                </a:lnTo>
-                <a:lnTo>
-                  <a:pt x="1768534" y="155056"/>
-                </a:lnTo>
-                <a:lnTo>
-                  <a:pt x="1821995" y="164899"/>
-                </a:lnTo>
-                <a:lnTo>
-                  <a:pt x="1875288" y="175044"/>
-                </a:lnTo>
-                <a:lnTo>
-                  <a:pt x="1928408" y="185492"/>
-                </a:lnTo>
-                <a:lnTo>
-                  <a:pt x="1981349" y="196243"/>
-                </a:lnTo>
-                <a:lnTo>
-                  <a:pt x="2034107" y="207297"/>
-                </a:lnTo>
-                <a:lnTo>
-                  <a:pt x="2086676" y="218654"/>
-                </a:lnTo>
-                <a:lnTo>
-                  <a:pt x="2139051" y="230314"/>
-                </a:lnTo>
-                <a:lnTo>
-                  <a:pt x="2191226" y="242276"/>
-                </a:lnTo>
-                <a:lnTo>
-                  <a:pt x="2243196" y="254541"/>
-                </a:lnTo>
-                <a:lnTo>
-                  <a:pt x="2294956" y="267109"/>
-                </a:lnTo>
-                <a:lnTo>
-                  <a:pt x="2346500" y="279980"/>
-                </a:lnTo>
-                <a:lnTo>
-                  <a:pt x="2397823" y="293154"/>
-                </a:lnTo>
-                <a:lnTo>
-                  <a:pt x="2448920" y="306631"/>
-                </a:lnTo>
-                <a:lnTo>
-                  <a:pt x="2499784" y="320410"/>
-                </a:lnTo>
-                <a:lnTo>
-                  <a:pt x="2550412" y="334492"/>
-                </a:lnTo>
-                <a:lnTo>
-                  <a:pt x="2600796" y="348878"/>
-                </a:lnTo>
-                <a:lnTo>
-                  <a:pt x="2650932" y="363566"/>
-                </a:lnTo>
-                <a:lnTo>
-                  <a:pt x="2700814" y="378556"/>
-                </a:lnTo>
-                <a:lnTo>
-                  <a:pt x="2750436" y="393850"/>
-                </a:lnTo>
-                <a:lnTo>
-                  <a:pt x="2799794" y="409447"/>
-                </a:lnTo>
-                <a:lnTo>
-                  <a:pt x="2848881" y="425346"/>
-                </a:lnTo>
-                <a:lnTo>
-                  <a:pt x="2897692" y="441548"/>
-                </a:lnTo>
-                <a:lnTo>
-                  <a:pt x="2946221" y="458053"/>
-                </a:lnTo>
-                <a:lnTo>
-                  <a:pt x="2994462" y="474861"/>
-                </a:lnTo>
-                <a:lnTo>
-                  <a:pt x="3042410" y="491972"/>
-                </a:lnTo>
-                <a:lnTo>
-                  <a:pt x="3090060" y="509386"/>
-                </a:lnTo>
-                <a:lnTo>
-                  <a:pt x="3137404" y="527102"/>
-                </a:lnTo>
-                <a:lnTo>
-                  <a:pt x="3184439" y="545121"/>
-                </a:lnTo>
-                <a:lnTo>
-                  <a:pt x="3231157" y="563444"/>
-                </a:lnTo>
-                <a:lnTo>
-                  <a:pt x="3277554" y="582069"/>
-                </a:lnTo>
-                <a:lnTo>
-                  <a:pt x="3323623" y="600996"/>
-                </a:lnTo>
-                <a:lnTo>
-                  <a:pt x="3369358" y="620227"/>
-                </a:lnTo>
-                <a:lnTo>
-                  <a:pt x="3414754" y="639761"/>
-                </a:lnTo>
-                <a:lnTo>
-                  <a:pt x="3459805" y="659597"/>
-                </a:lnTo>
-                <a:lnTo>
-                  <a:pt x="3504504" y="679736"/>
-                </a:lnTo>
-                <a:lnTo>
-                  <a:pt x="3548847" y="700178"/>
-                </a:lnTo>
-                <a:lnTo>
-                  <a:pt x="3592826" y="720923"/>
-                </a:lnTo>
-                <a:lnTo>
-                  <a:pt x="3636436" y="741971"/>
-                </a:lnTo>
-                <a:lnTo>
-                  <a:pt x="3679672" y="763321"/>
-                </a:lnTo>
-                <a:lnTo>
-                  <a:pt x="3722526" y="784975"/>
-                </a:lnTo>
-                <a:lnTo>
-                  <a:pt x="3764993" y="806931"/>
-                </a:lnTo>
-                <a:lnTo>
-                  <a:pt x="3807067" y="829190"/>
-                </a:lnTo>
-                <a:lnTo>
-                  <a:pt x="3848742" y="851752"/>
-                </a:lnTo>
-                <a:lnTo>
-                  <a:pt x="3890012" y="874617"/>
-                </a:lnTo>
-                <a:lnTo>
-                  <a:pt x="3930870" y="897785"/>
-                </a:lnTo>
-                <a:lnTo>
-                  <a:pt x="3971310" y="921255"/>
-                </a:lnTo>
-                <a:lnTo>
-                  <a:pt x="4011327" y="945029"/>
-                </a:lnTo>
-                <a:lnTo>
-                  <a:pt x="4050913" y="969105"/>
-                </a:lnTo>
-                <a:lnTo>
-                  <a:pt x="4090064" y="993484"/>
-                </a:lnTo>
-                <a:lnTo>
-                  <a:pt x="4128772" y="1018166"/>
-                </a:lnTo>
-                <a:lnTo>
-                  <a:pt x="4167032" y="1043151"/>
-                </a:lnTo>
-                <a:lnTo>
-                  <a:pt x="4204836" y="1068438"/>
-                </a:lnTo>
-                <a:lnTo>
-                  <a:pt x="4242180" y="1094029"/>
-                </a:lnTo>
-                <a:lnTo>
-                  <a:pt x="4279056" y="1119922"/>
-                </a:lnTo>
-                <a:lnTo>
-                  <a:pt x="4315458" y="1146118"/>
-                </a:lnTo>
-                <a:lnTo>
-                  <a:pt x="4351381" y="1172617"/>
-                </a:lnTo>
-                <a:lnTo>
-                  <a:pt x="4386817" y="1199419"/>
-                </a:lnTo>
-                <a:lnTo>
-                  <a:pt x="4421761" y="1226524"/>
-                </a:lnTo>
-                <a:lnTo>
-                  <a:pt x="4456206" y="1253931"/>
-                </a:lnTo>
-                <a:lnTo>
-                  <a:pt x="4490145" y="1281641"/>
-                </a:lnTo>
-                <a:lnTo>
-                  <a:pt x="4523574" y="1309655"/>
-                </a:lnTo>
-                <a:lnTo>
-                  <a:pt x="4556484" y="1337971"/>
-                </a:lnTo>
-                <a:lnTo>
-                  <a:pt x="4588871" y="1366590"/>
-                </a:lnTo>
-                <a:lnTo>
-                  <a:pt x="4620728" y="1395511"/>
-                </a:lnTo>
-                <a:lnTo>
-                  <a:pt x="4652048" y="1424736"/>
-                </a:lnTo>
-                <a:lnTo>
-                  <a:pt x="4682825" y="1454263"/>
-                </a:lnTo>
-                <a:lnTo>
-                  <a:pt x="4713054" y="1484094"/>
-                </a:lnTo>
-                <a:lnTo>
-                  <a:pt x="4742728" y="1514227"/>
-                </a:lnTo>
-                <a:lnTo>
-                  <a:pt x="4771841" y="1544663"/>
-                </a:lnTo>
-                <a:lnTo>
-                  <a:pt x="4800387" y="1575401"/>
-                </a:lnTo>
-                <a:lnTo>
-                  <a:pt x="4828359" y="1606443"/>
-                </a:lnTo>
-                <a:lnTo>
-                  <a:pt x="4855753" y="1637788"/>
-                </a:lnTo>
-                <a:lnTo>
-                  <a:pt x="4882562" y="1669435"/>
-                </a:lnTo>
-                <a:lnTo>
-                  <a:pt x="4908780" y="1701385"/>
-                </a:lnTo>
-                <a:lnTo>
-                  <a:pt x="4934402" y="1733638"/>
-                </a:lnTo>
-                <a:lnTo>
-                  <a:pt x="4959422" y="1766194"/>
-                </a:lnTo>
-                <a:lnTo>
-                  <a:pt x="4983834" y="1799053"/>
-                </a:lnTo>
-                <a:lnTo>
-                  <a:pt x="5007634" y="1832214"/>
-                </a:lnTo>
-                <a:lnTo>
-                  <a:pt x="5030815" y="1865679"/>
-                </a:lnTo>
-                <a:lnTo>
-                  <a:pt x="5053373" y="1899446"/>
-                </a:lnTo>
-                <a:lnTo>
-                  <a:pt x="5075303" y="1933516"/>
-                </a:lnTo>
-                <a:lnTo>
-                  <a:pt x="5096600" y="1967889"/>
-                </a:lnTo>
-                <a:lnTo>
-                  <a:pt x="5117259" y="2002565"/>
-                </a:lnTo>
-                <a:lnTo>
-                  <a:pt x="5137276" y="2037544"/>
-                </a:lnTo>
-                <a:lnTo>
-                  <a:pt x="5156647" y="2072825"/>
-                </a:lnTo>
-                <a:lnTo>
-                  <a:pt x="5175368" y="2108409"/>
-                </a:lnTo>
-                <a:lnTo>
-                  <a:pt x="5193434" y="2144297"/>
-                </a:lnTo>
-                <a:lnTo>
-                  <a:pt x="5210844" y="2180487"/>
-                </a:lnTo>
-                <a:lnTo>
-                  <a:pt x="5227594" y="2216979"/>
-                </a:lnTo>
-                <a:lnTo>
-                  <a:pt x="5243680" y="2253775"/>
-                </a:lnTo>
-                <a:lnTo>
-                  <a:pt x="5259101" y="2290874"/>
-                </a:lnTo>
-                <a:lnTo>
-                  <a:pt x="5273856" y="2328275"/>
-                </a:lnTo>
-                <a:lnTo>
-                  <a:pt x="5287941" y="2365979"/>
-                </a:lnTo>
-                <a:lnTo>
-                  <a:pt x="5301357" y="2403987"/>
-                </a:lnTo>
-                <a:lnTo>
-                  <a:pt x="5314103" y="2442296"/>
-                </a:lnTo>
-                <a:lnTo>
-                  <a:pt x="5326180" y="2480909"/>
-                </a:lnTo>
-                <a:lnTo>
-                  <a:pt x="5337587" y="2519825"/>
-                </a:lnTo>
-                <a:lnTo>
-                  <a:pt x="5348327" y="2559043"/>
-                </a:lnTo>
-                <a:lnTo>
-                  <a:pt x="5358402" y="2598565"/>
-                </a:lnTo>
-                <a:lnTo>
-                  <a:pt x="5367816" y="2638389"/>
-                </a:lnTo>
-                <a:lnTo>
-                  <a:pt x="5376571" y="2678516"/>
-                </a:lnTo>
-                <a:lnTo>
-                  <a:pt x="5384674" y="2718946"/>
-                </a:lnTo>
-                <a:lnTo>
-                  <a:pt x="5392130" y="2759678"/>
-                </a:lnTo>
-                <a:lnTo>
-                  <a:pt x="5398947" y="2800714"/>
-                </a:lnTo>
-                <a:lnTo>
-                  <a:pt x="5405135" y="2842052"/>
-                </a:lnTo>
-                <a:lnTo>
-                  <a:pt x="5410703" y="2883694"/>
-                </a:lnTo>
-                <a:lnTo>
-                  <a:pt x="5415663" y="2925638"/>
-                </a:lnTo>
-                <a:lnTo>
-                  <a:pt x="5420030" y="2967885"/>
-                </a:lnTo>
-                <a:lnTo>
-                  <a:pt x="5423821" y="3010434"/>
-                </a:lnTo>
-                <a:lnTo>
-                  <a:pt x="5427053" y="3053287"/>
-                </a:lnTo>
-                <a:lnTo>
-                  <a:pt x="5429750" y="3096443"/>
-                </a:lnTo>
-                <a:lnTo>
-                  <a:pt x="5431935" y="3139901"/>
-                </a:lnTo>
-                <a:lnTo>
-                  <a:pt x="5433640" y="3183662"/>
-                </a:lnTo>
-                <a:lnTo>
-                  <a:pt x="5434898" y="3227726"/>
-                </a:lnTo>
-                <a:lnTo>
-                  <a:pt x="5435752" y="3272093"/>
-                </a:lnTo>
-                <a:lnTo>
-                  <a:pt x="5436253" y="3316763"/>
-                </a:lnTo>
-                <a:lnTo>
-                  <a:pt x="5436468" y="3361735"/>
-                </a:lnTo>
-                <a:lnTo>
-                  <a:pt x="5436499" y="3395663"/>
+                  <a:pt x="22974" y="1"/>
+                </a:lnTo>
+                <a:lnTo>
+                  <a:pt x="45949" y="2"/>
+                </a:lnTo>
+                <a:lnTo>
+                  <a:pt x="68924" y="6"/>
+                </a:lnTo>
+                <a:lnTo>
+                  <a:pt x="91899" y="13"/>
+                </a:lnTo>
+                <a:lnTo>
+                  <a:pt x="114874" y="25"/>
+                </a:lnTo>
+                <a:lnTo>
+                  <a:pt x="137849" y="44"/>
+                </a:lnTo>
+                <a:lnTo>
+                  <a:pt x="160824" y="69"/>
+                </a:lnTo>
+                <a:lnTo>
+                  <a:pt x="183798" y="103"/>
+                </a:lnTo>
+                <a:lnTo>
+                  <a:pt x="206773" y="146"/>
+                </a:lnTo>
+                <a:lnTo>
+                  <a:pt x="229748" y="201"/>
+                </a:lnTo>
+                <a:lnTo>
+                  <a:pt x="252723" y="267"/>
+                </a:lnTo>
+                <a:lnTo>
+                  <a:pt x="275698" y="347"/>
+                </a:lnTo>
+                <a:lnTo>
+                  <a:pt x="298673" y="441"/>
+                </a:lnTo>
+                <a:lnTo>
+                  <a:pt x="321648" y="550"/>
+                </a:lnTo>
+                <a:lnTo>
+                  <a:pt x="344623" y="677"/>
+                </a:lnTo>
+                <a:lnTo>
+                  <a:pt x="367597" y="821"/>
+                </a:lnTo>
+                <a:lnTo>
+                  <a:pt x="390572" y="985"/>
+                </a:lnTo>
+                <a:lnTo>
+                  <a:pt x="413547" y="1169"/>
+                </a:lnTo>
+                <a:lnTo>
+                  <a:pt x="436522" y="1375"/>
+                </a:lnTo>
+                <a:lnTo>
+                  <a:pt x="459497" y="1604"/>
+                </a:lnTo>
+                <a:lnTo>
+                  <a:pt x="482472" y="1856"/>
+                </a:lnTo>
+                <a:lnTo>
+                  <a:pt x="505447" y="2134"/>
+                </a:lnTo>
+                <a:lnTo>
+                  <a:pt x="528422" y="2439"/>
+                </a:lnTo>
+                <a:lnTo>
+                  <a:pt x="551396" y="2771"/>
+                </a:lnTo>
+                <a:lnTo>
+                  <a:pt x="574371" y="3132"/>
+                </a:lnTo>
+                <a:lnTo>
+                  <a:pt x="597346" y="3523"/>
+                </a:lnTo>
+                <a:lnTo>
+                  <a:pt x="620321" y="3945"/>
+                </a:lnTo>
+                <a:lnTo>
+                  <a:pt x="643296" y="4400"/>
+                </a:lnTo>
+                <a:lnTo>
+                  <a:pt x="666271" y="4888"/>
+                </a:lnTo>
+                <a:lnTo>
+                  <a:pt x="689246" y="5412"/>
+                </a:lnTo>
+                <a:lnTo>
+                  <a:pt x="712221" y="5971"/>
+                </a:lnTo>
+                <a:lnTo>
+                  <a:pt x="735195" y="6568"/>
+                </a:lnTo>
+                <a:lnTo>
+                  <a:pt x="758170" y="7203"/>
+                </a:lnTo>
+                <a:lnTo>
+                  <a:pt x="781145" y="7878"/>
+                </a:lnTo>
+                <a:lnTo>
+                  <a:pt x="804120" y="8593"/>
+                </a:lnTo>
+                <a:lnTo>
+                  <a:pt x="827095" y="9351"/>
+                </a:lnTo>
+                <a:lnTo>
+                  <a:pt x="850070" y="10152"/>
+                </a:lnTo>
+                <a:lnTo>
+                  <a:pt x="873045" y="10998"/>
+                </a:lnTo>
+                <a:lnTo>
+                  <a:pt x="896020" y="11889"/>
+                </a:lnTo>
+                <a:lnTo>
+                  <a:pt x="918994" y="12827"/>
+                </a:lnTo>
+                <a:lnTo>
+                  <a:pt x="941969" y="13813"/>
+                </a:lnTo>
+                <a:lnTo>
+                  <a:pt x="964944" y="14849"/>
+                </a:lnTo>
+                <a:lnTo>
+                  <a:pt x="987919" y="15935"/>
+                </a:lnTo>
+                <a:lnTo>
+                  <a:pt x="1010894" y="17073"/>
+                </a:lnTo>
+                <a:lnTo>
+                  <a:pt x="1033869" y="18263"/>
+                </a:lnTo>
+                <a:lnTo>
+                  <a:pt x="1056844" y="19508"/>
+                </a:lnTo>
+                <a:lnTo>
+                  <a:pt x="1079819" y="20808"/>
+                </a:lnTo>
+                <a:lnTo>
+                  <a:pt x="1102793" y="22165"/>
+                </a:lnTo>
+                <a:lnTo>
+                  <a:pt x="1125768" y="23579"/>
+                </a:lnTo>
+                <a:lnTo>
+                  <a:pt x="1148743" y="25053"/>
+                </a:lnTo>
+                <a:lnTo>
+                  <a:pt x="1171718" y="26586"/>
+                </a:lnTo>
+                <a:lnTo>
+                  <a:pt x="1194693" y="28181"/>
+                </a:lnTo>
+                <a:lnTo>
+                  <a:pt x="1217668" y="29838"/>
+                </a:lnTo>
+                <a:lnTo>
+                  <a:pt x="1240643" y="31559"/>
+                </a:lnTo>
+                <a:lnTo>
+                  <a:pt x="1263618" y="33345"/>
+                </a:lnTo>
+                <a:lnTo>
+                  <a:pt x="1286592" y="35197"/>
+                </a:lnTo>
+                <a:lnTo>
+                  <a:pt x="1309567" y="37116"/>
+                </a:lnTo>
+                <a:lnTo>
+                  <a:pt x="1332542" y="39104"/>
+                </a:lnTo>
+                <a:lnTo>
+                  <a:pt x="1355517" y="41162"/>
+                </a:lnTo>
+                <a:lnTo>
+                  <a:pt x="1378492" y="43291"/>
+                </a:lnTo>
+                <a:lnTo>
+                  <a:pt x="1401467" y="45492"/>
+                </a:lnTo>
+                <a:lnTo>
+                  <a:pt x="1424442" y="47766"/>
+                </a:lnTo>
+                <a:lnTo>
+                  <a:pt x="1447417" y="50114"/>
+                </a:lnTo>
+                <a:lnTo>
+                  <a:pt x="1470391" y="52539"/>
+                </a:lnTo>
+                <a:lnTo>
+                  <a:pt x="1493366" y="55040"/>
+                </a:lnTo>
+                <a:lnTo>
+                  <a:pt x="1516341" y="57620"/>
+                </a:lnTo>
+                <a:lnTo>
+                  <a:pt x="1539316" y="60279"/>
+                </a:lnTo>
+                <a:lnTo>
+                  <a:pt x="1562291" y="63018"/>
+                </a:lnTo>
+                <a:lnTo>
+                  <a:pt x="1585266" y="65840"/>
+                </a:lnTo>
+                <a:lnTo>
+                  <a:pt x="1608241" y="68744"/>
+                </a:lnTo>
+                <a:lnTo>
+                  <a:pt x="1631216" y="71732"/>
+                </a:lnTo>
+                <a:lnTo>
+                  <a:pt x="1654190" y="74806"/>
+                </a:lnTo>
+                <a:lnTo>
+                  <a:pt x="1677165" y="77967"/>
+                </a:lnTo>
+                <a:lnTo>
+                  <a:pt x="1700140" y="81215"/>
+                </a:lnTo>
+                <a:lnTo>
+                  <a:pt x="1723115" y="84552"/>
+                </a:lnTo>
+                <a:lnTo>
+                  <a:pt x="1746090" y="87979"/>
+                </a:lnTo>
+                <a:lnTo>
+                  <a:pt x="1769065" y="91498"/>
+                </a:lnTo>
+                <a:lnTo>
+                  <a:pt x="1792040" y="95109"/>
+                </a:lnTo>
+                <a:lnTo>
+                  <a:pt x="1815015" y="98814"/>
+                </a:lnTo>
+                <a:lnTo>
+                  <a:pt x="1837989" y="102615"/>
+                </a:lnTo>
+                <a:lnTo>
+                  <a:pt x="1860964" y="106511"/>
+                </a:lnTo>
+                <a:lnTo>
+                  <a:pt x="1883939" y="110505"/>
+                </a:lnTo>
+                <a:lnTo>
+                  <a:pt x="1906914" y="114597"/>
+                </a:lnTo>
+                <a:lnTo>
+                  <a:pt x="1929889" y="118789"/>
+                </a:lnTo>
+                <a:lnTo>
+                  <a:pt x="1952864" y="123082"/>
+                </a:lnTo>
+                <a:lnTo>
+                  <a:pt x="1975839" y="127478"/>
+                </a:lnTo>
+                <a:lnTo>
+                  <a:pt x="1998814" y="131977"/>
+                </a:lnTo>
+                <a:lnTo>
+                  <a:pt x="2021788" y="136580"/>
+                </a:lnTo>
+                <a:lnTo>
+                  <a:pt x="2044763" y="141289"/>
+                </a:lnTo>
+                <a:lnTo>
+                  <a:pt x="2067738" y="146105"/>
+                </a:lnTo>
+                <a:lnTo>
+                  <a:pt x="2090713" y="151030"/>
+                </a:lnTo>
+                <a:lnTo>
+                  <a:pt x="2113688" y="156064"/>
+                </a:lnTo>
+                <a:lnTo>
+                  <a:pt x="2136663" y="161208"/>
+                </a:lnTo>
+                <a:lnTo>
+                  <a:pt x="2159638" y="166465"/>
+                </a:lnTo>
+                <a:lnTo>
+                  <a:pt x="2182613" y="171834"/>
+                </a:lnTo>
+                <a:lnTo>
+                  <a:pt x="2205587" y="177318"/>
+                </a:lnTo>
+                <a:lnTo>
+                  <a:pt x="2228562" y="182917"/>
+                </a:lnTo>
+                <a:lnTo>
+                  <a:pt x="2251537" y="188633"/>
+                </a:lnTo>
+                <a:lnTo>
+                  <a:pt x="2274512" y="194466"/>
+                </a:lnTo>
+                <a:lnTo>
+                  <a:pt x="2297487" y="200419"/>
+                </a:lnTo>
+                <a:lnTo>
+                  <a:pt x="2320462" y="206492"/>
+                </a:lnTo>
+                <a:lnTo>
+                  <a:pt x="2343437" y="212686"/>
+                </a:lnTo>
+                <a:lnTo>
+                  <a:pt x="2366412" y="219003"/>
+                </a:lnTo>
+                <a:lnTo>
+                  <a:pt x="2389386" y="225444"/>
+                </a:lnTo>
+                <a:lnTo>
+                  <a:pt x="2412361" y="232010"/>
+                </a:lnTo>
+                <a:lnTo>
+                  <a:pt x="2435336" y="238702"/>
+                </a:lnTo>
+                <a:lnTo>
+                  <a:pt x="2458311" y="245522"/>
+                </a:lnTo>
+                <a:lnTo>
+                  <a:pt x="2481286" y="252470"/>
+                </a:lnTo>
+                <a:lnTo>
+                  <a:pt x="2504261" y="259548"/>
+                </a:lnTo>
+                <a:lnTo>
+                  <a:pt x="2527236" y="266757"/>
+                </a:lnTo>
+                <a:lnTo>
+                  <a:pt x="2550211" y="274099"/>
+                </a:lnTo>
+                <a:lnTo>
+                  <a:pt x="2573185" y="281574"/>
+                </a:lnTo>
+                <a:lnTo>
+                  <a:pt x="2596160" y="289184"/>
+                </a:lnTo>
+                <a:lnTo>
+                  <a:pt x="2619135" y="296929"/>
+                </a:lnTo>
+                <a:lnTo>
+                  <a:pt x="2642110" y="304812"/>
+                </a:lnTo>
+                <a:lnTo>
+                  <a:pt x="2665085" y="312833"/>
+                </a:lnTo>
+                <a:lnTo>
+                  <a:pt x="2688060" y="320993"/>
+                </a:lnTo>
+                <a:lnTo>
+                  <a:pt x="2711035" y="329294"/>
+                </a:lnTo>
+                <a:lnTo>
+                  <a:pt x="2734010" y="337737"/>
+                </a:lnTo>
+                <a:lnTo>
+                  <a:pt x="2756984" y="346324"/>
+                </a:lnTo>
+                <a:lnTo>
+                  <a:pt x="2779959" y="355054"/>
+                </a:lnTo>
+                <a:lnTo>
+                  <a:pt x="2802934" y="363930"/>
+                </a:lnTo>
+                <a:lnTo>
+                  <a:pt x="2825909" y="372953"/>
+                </a:lnTo>
+                <a:lnTo>
+                  <a:pt x="2848884" y="382123"/>
+                </a:lnTo>
+                <a:lnTo>
+                  <a:pt x="2871859" y="391443"/>
+                </a:lnTo>
+                <a:lnTo>
+                  <a:pt x="2894834" y="400913"/>
+                </a:lnTo>
+                <a:lnTo>
+                  <a:pt x="2917809" y="410534"/>
+                </a:lnTo>
+                <a:lnTo>
+                  <a:pt x="2940783" y="420308"/>
+                </a:lnTo>
+                <a:lnTo>
+                  <a:pt x="2963758" y="430237"/>
+                </a:lnTo>
+                <a:lnTo>
+                  <a:pt x="2986733" y="440320"/>
+                </a:lnTo>
+                <a:lnTo>
+                  <a:pt x="3009708" y="450559"/>
+                </a:lnTo>
+                <a:lnTo>
+                  <a:pt x="3032683" y="460957"/>
+                </a:lnTo>
+                <a:lnTo>
+                  <a:pt x="3055658" y="471512"/>
+                </a:lnTo>
+                <a:lnTo>
+                  <a:pt x="3078633" y="482228"/>
+                </a:lnTo>
+                <a:lnTo>
+                  <a:pt x="3101608" y="493105"/>
+                </a:lnTo>
+                <a:lnTo>
+                  <a:pt x="3124582" y="504144"/>
+                </a:lnTo>
+                <a:lnTo>
+                  <a:pt x="3147557" y="515347"/>
+                </a:lnTo>
+                <a:lnTo>
+                  <a:pt x="3170532" y="526715"/>
+                </a:lnTo>
+                <a:lnTo>
+                  <a:pt x="3193507" y="538248"/>
+                </a:lnTo>
+                <a:lnTo>
+                  <a:pt x="3216482" y="549949"/>
+                </a:lnTo>
+                <a:lnTo>
+                  <a:pt x="3239457" y="561818"/>
+                </a:lnTo>
+                <a:lnTo>
+                  <a:pt x="3262432" y="573856"/>
+                </a:lnTo>
+                <a:lnTo>
+                  <a:pt x="3285407" y="586066"/>
+                </a:lnTo>
+                <a:lnTo>
+                  <a:pt x="3308381" y="598447"/>
+                </a:lnTo>
+                <a:lnTo>
+                  <a:pt x="3331356" y="611001"/>
+                </a:lnTo>
+                <a:lnTo>
+                  <a:pt x="3354331" y="623730"/>
+                </a:lnTo>
+                <a:lnTo>
+                  <a:pt x="3377306" y="636634"/>
+                </a:lnTo>
+                <a:lnTo>
+                  <a:pt x="3400281" y="649716"/>
+                </a:lnTo>
+                <a:lnTo>
+                  <a:pt x="3423256" y="662975"/>
+                </a:lnTo>
+                <a:lnTo>
+                  <a:pt x="3446231" y="676413"/>
+                </a:lnTo>
+                <a:lnTo>
+                  <a:pt x="3469206" y="690032"/>
+                </a:lnTo>
+                <a:lnTo>
+                  <a:pt x="3492180" y="703832"/>
+                </a:lnTo>
+                <a:lnTo>
+                  <a:pt x="3515155" y="717815"/>
+                </a:lnTo>
+                <a:lnTo>
+                  <a:pt x="3538130" y="731982"/>
+                </a:lnTo>
+                <a:lnTo>
+                  <a:pt x="3561105" y="746334"/>
+                </a:lnTo>
+                <a:lnTo>
+                  <a:pt x="3584080" y="760872"/>
+                </a:lnTo>
+                <a:lnTo>
+                  <a:pt x="3607055" y="775599"/>
+                </a:lnTo>
+                <a:lnTo>
+                  <a:pt x="3630030" y="790514"/>
+                </a:lnTo>
+                <a:lnTo>
+                  <a:pt x="3653005" y="805619"/>
+                </a:lnTo>
+                <a:lnTo>
+                  <a:pt x="3675979" y="820915"/>
+                </a:lnTo>
+                <a:lnTo>
+                  <a:pt x="3698954" y="836403"/>
+                </a:lnTo>
+                <a:lnTo>
+                  <a:pt x="3721929" y="852085"/>
+                </a:lnTo>
+                <a:lnTo>
+                  <a:pt x="3744904" y="867962"/>
+                </a:lnTo>
+                <a:lnTo>
+                  <a:pt x="3767879" y="884035"/>
+                </a:lnTo>
+                <a:lnTo>
+                  <a:pt x="3790854" y="900305"/>
+                </a:lnTo>
+                <a:lnTo>
+                  <a:pt x="3813829" y="916774"/>
+                </a:lnTo>
+                <a:lnTo>
+                  <a:pt x="3836804" y="933442"/>
+                </a:lnTo>
+                <a:lnTo>
+                  <a:pt x="3859778" y="950311"/>
+                </a:lnTo>
+                <a:lnTo>
+                  <a:pt x="3882753" y="967382"/>
+                </a:lnTo>
+                <a:lnTo>
+                  <a:pt x="3905728" y="984657"/>
+                </a:lnTo>
+                <a:lnTo>
+                  <a:pt x="3928703" y="1002135"/>
+                </a:lnTo>
+                <a:lnTo>
+                  <a:pt x="3951678" y="1019820"/>
+                </a:lnTo>
+                <a:lnTo>
+                  <a:pt x="3974653" y="1037711"/>
+                </a:lnTo>
+                <a:lnTo>
+                  <a:pt x="3997628" y="1055810"/>
+                </a:lnTo>
+                <a:lnTo>
+                  <a:pt x="4020603" y="1074118"/>
+                </a:lnTo>
+                <a:lnTo>
+                  <a:pt x="4043577" y="1092637"/>
+                </a:lnTo>
+                <a:lnTo>
+                  <a:pt x="4066552" y="1111368"/>
+                </a:lnTo>
+                <a:lnTo>
+                  <a:pt x="4089527" y="1130311"/>
+                </a:lnTo>
+                <a:lnTo>
+                  <a:pt x="4112502" y="1149469"/>
+                </a:lnTo>
+                <a:lnTo>
+                  <a:pt x="4135477" y="1168841"/>
+                </a:lnTo>
+                <a:lnTo>
+                  <a:pt x="4158452" y="1188430"/>
+                </a:lnTo>
+                <a:lnTo>
+                  <a:pt x="4181427" y="1208237"/>
+                </a:lnTo>
+                <a:lnTo>
+                  <a:pt x="4204402" y="1228263"/>
+                </a:lnTo>
+                <a:lnTo>
+                  <a:pt x="4227376" y="1248508"/>
+                </a:lnTo>
+                <a:lnTo>
+                  <a:pt x="4250351" y="1268975"/>
+                </a:lnTo>
+                <a:lnTo>
+                  <a:pt x="4273326" y="1289665"/>
+                </a:lnTo>
+                <a:lnTo>
+                  <a:pt x="4296301" y="1310578"/>
+                </a:lnTo>
+                <a:lnTo>
+                  <a:pt x="4319276" y="1331716"/>
+                </a:lnTo>
+                <a:lnTo>
+                  <a:pt x="4342251" y="1353080"/>
+                </a:lnTo>
+                <a:lnTo>
+                  <a:pt x="4365226" y="1374671"/>
+                </a:lnTo>
+                <a:lnTo>
+                  <a:pt x="4388201" y="1396491"/>
+                </a:lnTo>
+                <a:lnTo>
+                  <a:pt x="4411175" y="1418540"/>
+                </a:lnTo>
+                <a:lnTo>
+                  <a:pt x="4434150" y="1440821"/>
+                </a:lnTo>
+                <a:lnTo>
+                  <a:pt x="4457125" y="1463333"/>
+                </a:lnTo>
+                <a:lnTo>
+                  <a:pt x="4480100" y="1486079"/>
+                </a:lnTo>
+                <a:lnTo>
+                  <a:pt x="4503075" y="1509059"/>
+                </a:lnTo>
+                <a:lnTo>
+                  <a:pt x="4526050" y="1532275"/>
+                </a:lnTo>
+                <a:lnTo>
+                  <a:pt x="4549025" y="1555728"/>
+                </a:lnTo>
+                <a:lnTo>
+                  <a:pt x="4572000" y="1579419"/>
                 </a:lnTo>
               </a:path>
             </a:pathLst>
@@ -4951,19 +5735,19 @@
       </p:sp>
       <p:cxnSp>
         <p:nvCxnSpPr>
-          <p:cNvPr id="49" name="C1-E13 line 47" descr="sci-ppt:o047"/>
+          <p:cNvPr id="57" name="C1-E13 line 55" descr="sci-ppt:o055"/>
           <p:cNvCxnSpPr/>
           <p:nvPr/>
         </p:nvCxnSpPr>
         <p:spPr>
           <a:xfrm>
-            <a:off x="11014339" y="1371600"/>
-            <a:ext cx="0" cy="3566160"/>
+            <a:off x="9189720" y="4096626"/>
+            <a:ext cx="1600200" cy="335824"/>
           </a:xfrm>
           <a:prstGeom prst="line">
             <a:avLst/>
           </a:prstGeom>
-          <a:ln w="16510">
+          <a:ln w="25400">
             <a:solidFill>
               <a:srgbClr val="F2B880"/>
             </a:solidFill>
@@ -4974,126 +5758,14 @@
       </p:cxnSp>
       <p:sp>
         <p:nvSpPr>
-          <p:cNvPr id="50" name="C1-E13 text 48" descr="sci-ppt:o048"/>
+          <p:cNvPr id="58" name="C1-E13 text 56" descr="sci-ppt:o056"/>
           <p:cNvSpPr txBox="1"/>
           <p:nvPr/>
         </p:nvSpPr>
         <p:spPr>
           <a:xfrm>
-            <a:off x="9231259" y="3069771"/>
-            <a:ext cx="1737360" cy="247142"/>
-          </a:xfrm>
-          <a:prstGeom prst="rect">
-            <a:avLst/>
-          </a:prstGeom>
-          <a:noFill/>
-          <a:effectLst/>
-        </p:spPr>
-        <p:txBody>
-          <a:bodyPr wrap="none" lIns="18288" rIns="18288" tIns="18288" bIns="18288" anchor="t">
-            <a:spAutoFit/>
-          </a:bodyPr>
-          <a:lstStyle/>
-          <a:p>
-            <a:pPr algn="l">
-              <a:spcAft>
-                <a:spcPts val="0"/>
-              </a:spcAft>
-            </a:pPr>
-            <a:r>
-              <a:rPr sz="1300" b="0" i="0">
-                <a:solidFill>
-                  <a:srgbClr val="F2B880"/>
-                </a:solidFill>
-                <a:latin typeface="Arial"/>
-              </a:rPr>
-              <a:t>t_c = 2.74 µs</a:t>
-            </a:r>
-          </a:p>
-        </p:txBody>
-      </p:sp>
-      <p:sp>
-        <p:nvSpPr>
-          <p:cNvPr id="51" name="C1-E13 ellipse 49" descr="sci-ppt:o049"/>
-          <p:cNvSpPr/>
-          <p:nvPr/>
-        </p:nvSpPr>
-        <p:spPr>
-          <a:xfrm>
-            <a:off x="5504688" y="1468265"/>
-            <a:ext cx="146304" cy="146304"/>
-          </a:xfrm>
-          <a:prstGeom prst="ellipse">
-            <a:avLst/>
-          </a:prstGeom>
-          <a:solidFill>
-            <a:srgbClr val="F2B880"/>
-          </a:solidFill>
-          <a:ln w="12700">
-            <a:solidFill>
-              <a:srgbClr val="F2B880"/>
-            </a:solidFill>
-          </a:ln>
-          <a:effectLst/>
-        </p:spPr>
-        <p:txBody>
-          <a:bodyPr rtlCol="0" anchor="ctr"/>
-          <a:lstStyle/>
-          <a:p>
-            <a:pPr algn="ctr"/>
-          </a:p>
-        </p:txBody>
-      </p:sp>
-      <p:sp>
-        <p:nvSpPr>
-          <p:cNvPr id="52" name="C1-E13 text 50" descr="sci-ppt:o050"/>
-          <p:cNvSpPr txBox="1"/>
-          <p:nvPr/>
-        </p:nvSpPr>
-        <p:spPr>
-          <a:xfrm>
-            <a:off x="5786628" y="1632857"/>
-            <a:ext cx="2011680" cy="231648"/>
-          </a:xfrm>
-          <a:prstGeom prst="rect">
-            <a:avLst/>
-          </a:prstGeom>
-          <a:noFill/>
-          <a:effectLst/>
-        </p:spPr>
-        <p:txBody>
-          <a:bodyPr wrap="none" lIns="18288" rIns="18288" tIns="18288" bIns="18288" anchor="t">
-            <a:spAutoFit/>
-          </a:bodyPr>
-          <a:lstStyle/>
-          <a:p>
-            <a:pPr algn="l">
-              <a:spcAft>
-                <a:spcPts val="0"/>
-              </a:spcAft>
-            </a:pPr>
-            <a:r>
-              <a:rPr sz="1200" b="0" i="0">
-                <a:solidFill>
-                  <a:srgbClr val="F2B880"/>
-                </a:solidFill>
-                <a:latin typeface="Arial"/>
-              </a:rPr>
-              <a:t>flat start (Ṙ = 0)</a:t>
-            </a:r>
-          </a:p>
-        </p:txBody>
-      </p:sp>
-      <p:sp>
-        <p:nvSpPr>
-          <p:cNvPr id="53" name="C1-E13 text 51" descr="sci-ppt:o051"/>
-          <p:cNvSpPr txBox="1"/>
-          <p:nvPr/>
-        </p:nvSpPr>
-        <p:spPr>
-          <a:xfrm>
-            <a:off x="8325612" y="4438758"/>
-            <a:ext cx="2011680" cy="231648"/>
+            <a:off x="7434072" y="4645152"/>
+            <a:ext cx="2926080" cy="231648"/>
           </a:xfrm>
           <a:prstGeom prst="rect">
             <a:avLst/>
@@ -5119,21 +5791,53 @@
                 </a:solidFill>
                 <a:latin typeface="Arial"/>
               </a:rPr>
-              <a:t>steepest at the end</a:t>
-            </a:r>
-          </a:p>
-        </p:txBody>
-      </p:sp>
-      <p:sp>
-        <p:nvSpPr>
-          <p:cNvPr id="54" name="C1-E13 text 52" descr="sci-ppt:o052"/>
+              <a:t>R³y = 1 − x³: simple, slope ∝ −R²</a:t>
+            </a:r>
+          </a:p>
+        </p:txBody>
+      </p:sp>
+      <p:sp>
+        <p:nvSpPr>
+          <p:cNvPr id="59" name="C1-E13 round_rect 57" descr="sci-ppt:o057"/>
+          <p:cNvSpPr/>
+          <p:nvPr/>
+        </p:nvSpPr>
+        <p:spPr>
+          <a:xfrm>
+            <a:off x="365760" y="914400"/>
+            <a:ext cx="5852160" cy="4937760"/>
+          </a:xfrm>
+          <a:prstGeom prst="roundRect">
+            <a:avLst/>
+          </a:prstGeom>
+          <a:solidFill>
+            <a:srgbClr val="213E4B"/>
+          </a:solidFill>
+          <a:ln w="20320">
+            <a:solidFill>
+              <a:srgbClr val="8EDBD4"/>
+            </a:solidFill>
+          </a:ln>
+          <a:effectLst/>
+        </p:spPr>
+        <p:txBody>
+          <a:bodyPr rtlCol="0" anchor="ctr"/>
+          <a:lstStyle/>
+          <a:p>
+            <a:pPr algn="ctr"/>
+          </a:p>
+        </p:txBody>
+      </p:sp>
+      <p:sp>
+        <p:nvSpPr>
+          <p:cNvPr id="60" name="C1-E13 text 58" descr="sci-ppt:o058"/>
           <p:cNvSpPr txBox="1"/>
           <p:nvPr/>
         </p:nvSpPr>
         <p:spPr>
           <a:xfrm>
-            <a:off x="5577840" y="5733288"/>
-            <a:ext cx="6035040" cy="254889"/>
+            <a:off x="475488" y="969264"/>
+            <a:ext cx="5632704" cy="254889"/>
           </a:xfrm>
           <a:prstGeom prst="rect">
             <a:avLst/>
@@ -5155,25 +5859,25 @@
             <a:r>
               <a:rPr sz="1350" b="1" i="0">
                 <a:solidFill>
-                  <a:srgbClr val="E7F0F3"/>
+                  <a:srgbClr val="8EDBD4"/>
                 </a:solidFill>
                 <a:latin typeface="Arial"/>
               </a:rPr>
-              <a:t>R R̈ + (3/2)Ṙ² = −Δp_c/ρ,  R(0) = Rₘₐₓ,  Ṙ(0) = 0</a:t>
-            </a:r>
-          </a:p>
-        </p:txBody>
-      </p:sp>
-      <p:sp>
-        <p:nvSpPr>
-          <p:cNvPr id="55" name="C1-E13 text 53" descr="sci-ppt:o053"/>
+              <a:t>Why the radius replaces time</a:t>
+            </a:r>
+          </a:p>
+        </p:txBody>
+      </p:sp>
+      <p:sp>
+        <p:nvSpPr>
+          <p:cNvPr id="61" name="C1-E13 text 59" descr="sci-ppt:o059"/>
           <p:cNvSpPr txBox="1"/>
           <p:nvPr/>
         </p:nvSpPr>
         <p:spPr>
           <a:xfrm>
-            <a:off x="5577840" y="6108192"/>
-            <a:ext cx="6035040" cy="433070"/>
+            <a:off x="548640" y="1417320"/>
+            <a:ext cx="5394960" cy="247142"/>
           </a:xfrm>
           <a:prstGeom prst="rect">
             <a:avLst/>
@@ -5193,15 +5897,39 @@
               </a:spcAft>
             </a:pPr>
             <a:r>
-              <a:rPr sz="1250" b="0" i="0">
+              <a:rPr sz="1300" b="1" i="0">
                 <a:solidFill>
                   <a:srgbClr val="F2B880"/>
                 </a:solidFill>
                 <a:latin typeface="Arial"/>
               </a:rPr>
-              <a:t>The model has no gas, viscosity, tension or compressibility, so nothing</a:t>
-            </a:r>
-          </a:p>
+              <a:t>1  y(R) = Ṙ²,  Ṙ ≠ 0</a:t>
+            </a:r>
+          </a:p>
+        </p:txBody>
+      </p:sp>
+      <p:sp>
+        <p:nvSpPr>
+          <p:cNvPr id="62" name="C1-E13 text 60" descr="sci-ppt:o060"/>
+          <p:cNvSpPr txBox="1"/>
+          <p:nvPr/>
+        </p:nvSpPr>
+        <p:spPr>
+          <a:xfrm>
+            <a:off x="777240" y="1728216"/>
+            <a:ext cx="5212080" cy="247142"/>
+          </a:xfrm>
+          <a:prstGeom prst="rect">
+            <a:avLst/>
+          </a:prstGeom>
+          <a:noFill/>
+          <a:effectLst/>
+        </p:spPr>
+        <p:txBody>
+          <a:bodyPr wrap="none" lIns="18288" rIns="18288" tIns="18288" bIns="18288" anchor="t">
+            <a:spAutoFit/>
+          </a:bodyPr>
+          <a:lstStyle/>
           <a:p>
             <a:pPr algn="l">
               <a:spcAft>
@@ -5209,20 +5937,316 @@
               </a:spcAft>
             </a:pPr>
             <a:r>
-              <a:rPr sz="1250" b="0" i="0">
+              <a:rPr sz="1300" b="0" i="0">
+                <a:solidFill>
+                  <a:srgbClr val="E7F0F3"/>
+                </a:solidFill>
+                <a:latin typeface="Arial"/>
+              </a:rPr>
+              <a:t>dy/dR = 2R̈</a:t>
+            </a:r>
+          </a:p>
+        </p:txBody>
+      </p:sp>
+      <p:sp>
+        <p:nvSpPr>
+          <p:cNvPr id="63" name="C1-E13 text 61" descr="sci-ppt:o061"/>
+          <p:cNvSpPr txBox="1"/>
+          <p:nvPr/>
+        </p:nvSpPr>
+        <p:spPr>
+          <a:xfrm>
+            <a:off x="548640" y="2249678"/>
+            <a:ext cx="5394960" cy="247142"/>
+          </a:xfrm>
+          <a:prstGeom prst="rect">
+            <a:avLst/>
+          </a:prstGeom>
+          <a:noFill/>
+          <a:effectLst/>
+        </p:spPr>
+        <p:txBody>
+          <a:bodyPr wrap="none" lIns="18288" rIns="18288" tIns="18288" bIns="18288" anchor="t">
+            <a:spAutoFit/>
+          </a:bodyPr>
+          <a:lstStyle/>
+          <a:p>
+            <a:pPr algn="l">
+              <a:spcAft>
+                <a:spcPts val="0"/>
+              </a:spcAft>
+            </a:pPr>
+            <a:r>
+              <a:rPr sz="1300" b="1" i="0">
                 <a:solidFill>
                   <a:srgbClr val="F2B880"/>
                 </a:solidFill>
                 <a:latin typeface="Arial"/>
               </a:rPr>
-              <a:t>stops the collapse.</a:t>
-            </a:r>
-          </a:p>
-        </p:txBody>
-      </p:sp>
-      <p:sp>
-        <p:nvSpPr>
-          <p:cNvPr id="56" name="C1-E13 text 54" descr="sci-ppt:o054"/>
+              <a:t>2  Rewrite R R̈ + (3/2)Ṙ² = −Δp_c/ρ</a:t>
+            </a:r>
+          </a:p>
+        </p:txBody>
+      </p:sp>
+      <p:sp>
+        <p:nvSpPr>
+          <p:cNvPr id="64" name="C1-E13 text 62" descr="sci-ppt:o062"/>
+          <p:cNvSpPr txBox="1"/>
+          <p:nvPr/>
+        </p:nvSpPr>
+        <p:spPr>
+          <a:xfrm>
+            <a:off x="777240" y="2560574"/>
+            <a:ext cx="5212080" cy="247142"/>
+          </a:xfrm>
+          <a:prstGeom prst="rect">
+            <a:avLst/>
+          </a:prstGeom>
+          <a:noFill/>
+          <a:effectLst/>
+        </p:spPr>
+        <p:txBody>
+          <a:bodyPr wrap="none" lIns="18288" rIns="18288" tIns="18288" bIns="18288" anchor="t">
+            <a:spAutoFit/>
+          </a:bodyPr>
+          <a:lstStyle/>
+          <a:p>
+            <a:pPr algn="l">
+              <a:spcAft>
+                <a:spcPts val="0"/>
+              </a:spcAft>
+            </a:pPr>
+            <a:r>
+              <a:rPr sz="1300" b="0" i="0">
+                <a:solidFill>
+                  <a:srgbClr val="E7F0F3"/>
+                </a:solidFill>
+                <a:latin typeface="Arial"/>
+              </a:rPr>
+              <a:t>y′ + 3y/R = −2Δp_c/(ρR)</a:t>
+            </a:r>
+          </a:p>
+        </p:txBody>
+      </p:sp>
+      <p:sp>
+        <p:nvSpPr>
+          <p:cNvPr id="65" name="C1-E13 text 63" descr="sci-ppt:o063"/>
+          <p:cNvSpPr txBox="1"/>
+          <p:nvPr/>
+        </p:nvSpPr>
+        <p:spPr>
+          <a:xfrm>
+            <a:off x="548640" y="3082036"/>
+            <a:ext cx="5394960" cy="247142"/>
+          </a:xfrm>
+          <a:prstGeom prst="rect">
+            <a:avLst/>
+          </a:prstGeom>
+          <a:noFill/>
+          <a:effectLst/>
+        </p:spPr>
+        <p:txBody>
+          <a:bodyPr wrap="none" lIns="18288" rIns="18288" tIns="18288" bIns="18288" anchor="t">
+            <a:spAutoFit/>
+          </a:bodyPr>
+          <a:lstStyle/>
+          <a:p>
+            <a:pPr algn="l">
+              <a:spcAft>
+                <a:spcPts val="0"/>
+              </a:spcAft>
+            </a:pPr>
+            <a:r>
+              <a:rPr sz="1300" b="1" i="0">
+                <a:solidFill>
+                  <a:srgbClr val="F2B880"/>
+                </a:solidFill>
+                <a:latin typeface="Arial"/>
+              </a:rPr>
+              <a:t>3  Multiply by the integrating factor R³</a:t>
+            </a:r>
+          </a:p>
+        </p:txBody>
+      </p:sp>
+      <p:sp>
+        <p:nvSpPr>
+          <p:cNvPr id="66" name="C1-E13 text 64" descr="sci-ppt:o064"/>
+          <p:cNvSpPr txBox="1"/>
+          <p:nvPr/>
+        </p:nvSpPr>
+        <p:spPr>
+          <a:xfrm>
+            <a:off x="777240" y="3392931"/>
+            <a:ext cx="5212080" cy="247142"/>
+          </a:xfrm>
+          <a:prstGeom prst="rect">
+            <a:avLst/>
+          </a:prstGeom>
+          <a:noFill/>
+          <a:effectLst/>
+        </p:spPr>
+        <p:txBody>
+          <a:bodyPr wrap="none" lIns="18288" rIns="18288" tIns="18288" bIns="18288" anchor="t">
+            <a:spAutoFit/>
+          </a:bodyPr>
+          <a:lstStyle/>
+          <a:p>
+            <a:pPr algn="l">
+              <a:spcAft>
+                <a:spcPts val="0"/>
+              </a:spcAft>
+            </a:pPr>
+            <a:r>
+              <a:rPr sz="1300" b="0" i="0">
+                <a:solidFill>
+                  <a:srgbClr val="E7F0F3"/>
+                </a:solidFill>
+                <a:latin typeface="Arial"/>
+              </a:rPr>
+              <a:t>d(R³y)/dR = R³y′ + 3R²y = −(2Δp_c/ρ) R²</a:t>
+            </a:r>
+          </a:p>
+        </p:txBody>
+      </p:sp>
+      <p:sp>
+        <p:nvSpPr>
+          <p:cNvPr id="67" name="C1-E13 text 65" descr="sci-ppt:o065"/>
+          <p:cNvSpPr txBox="1"/>
+          <p:nvPr/>
+        </p:nvSpPr>
+        <p:spPr>
+          <a:xfrm>
+            <a:off x="548640" y="3914393"/>
+            <a:ext cx="5394960" cy="247142"/>
+          </a:xfrm>
+          <a:prstGeom prst="rect">
+            <a:avLst/>
+          </a:prstGeom>
+          <a:noFill/>
+          <a:effectLst/>
+        </p:spPr>
+        <p:txBody>
+          <a:bodyPr wrap="none" lIns="18288" rIns="18288" tIns="18288" bIns="18288" anchor="t">
+            <a:spAutoFit/>
+          </a:bodyPr>
+          <a:lstStyle/>
+          <a:p>
+            <a:pPr algn="l">
+              <a:spcAft>
+                <a:spcPts val="0"/>
+              </a:spcAft>
+            </a:pPr>
+            <a:r>
+              <a:rPr sz="1300" b="1" i="0">
+                <a:solidFill>
+                  <a:srgbClr val="F2B880"/>
+                </a:solidFill>
+                <a:latin typeface="Arial"/>
+              </a:rPr>
+              <a:t>4  Integrate from Rₘₐₓ (y = 0)</a:t>
+            </a:r>
+          </a:p>
+        </p:txBody>
+      </p:sp>
+      <p:sp>
+        <p:nvSpPr>
+          <p:cNvPr id="68" name="C1-E13 text 66" descr="sci-ppt:o066"/>
+          <p:cNvSpPr txBox="1"/>
+          <p:nvPr/>
+        </p:nvSpPr>
+        <p:spPr>
+          <a:xfrm>
+            <a:off x="777240" y="4225289"/>
+            <a:ext cx="5212080" cy="247142"/>
+          </a:xfrm>
+          <a:prstGeom prst="rect">
+            <a:avLst/>
+          </a:prstGeom>
+          <a:noFill/>
+          <a:effectLst/>
+        </p:spPr>
+        <p:txBody>
+          <a:bodyPr wrap="none" lIns="18288" rIns="18288" tIns="18288" bIns="18288" anchor="t">
+            <a:spAutoFit/>
+          </a:bodyPr>
+          <a:lstStyle/>
+          <a:p>
+            <a:pPr algn="l">
+              <a:spcAft>
+                <a:spcPts val="0"/>
+              </a:spcAft>
+            </a:pPr>
+            <a:r>
+              <a:rPr sz="1300" b="0" i="0">
+                <a:solidFill>
+                  <a:srgbClr val="E7F0F3"/>
+                </a:solidFill>
+                <a:latin typeface="Arial"/>
+              </a:rPr>
+              <a:t>R³y = (2Δp_c/3ρ)(Rₘₐₓ³ − R³)</a:t>
+            </a:r>
+          </a:p>
+        </p:txBody>
+      </p:sp>
+      <p:sp>
+        <p:nvSpPr>
+          <p:cNvPr id="69" name="C1-E13 text 67" descr="sci-ppt:o067"/>
+          <p:cNvSpPr txBox="1"/>
+          <p:nvPr/>
+        </p:nvSpPr>
+        <p:spPr>
+          <a:xfrm>
+            <a:off x="548640" y="4792471"/>
+            <a:ext cx="5394960" cy="433070"/>
+          </a:xfrm>
+          <a:prstGeom prst="rect">
+            <a:avLst/>
+          </a:prstGeom>
+          <a:noFill/>
+          <a:effectLst/>
+        </p:spPr>
+        <p:txBody>
+          <a:bodyPr wrap="none" lIns="18288" rIns="18288" tIns="18288" bIns="18288" anchor="t">
+            <a:spAutoFit/>
+          </a:bodyPr>
+          <a:lstStyle/>
+          <a:p>
+            <a:pPr algn="l">
+              <a:spcAft>
+                <a:spcPts val="0"/>
+              </a:spcAft>
+            </a:pPr>
+            <a:r>
+              <a:rPr sz="1250" b="0" i="0">
+                <a:solidFill>
+                  <a:srgbClr val="B4C7D2"/>
+                </a:solidFill>
+                <a:latin typeface="Arial"/>
+              </a:rPr>
+              <a:t>On the monotonic inward branch R is a valid independent</a:t>
+            </a:r>
+          </a:p>
+          <a:p>
+            <a:pPr algn="l">
+              <a:spcAft>
+                <a:spcPts val="0"/>
+              </a:spcAft>
+            </a:pPr>
+            <a:r>
+              <a:rPr sz="1250" b="0" i="0">
+                <a:solidFill>
+                  <a:srgbClr val="B4C7D2"/>
+                </a:solidFill>
+                <a:latin typeface="Arial"/>
+              </a:rPr>
+              <a:t>variable. The factor R³ makes the left side an exact derivative.</a:t>
+            </a:r>
+          </a:p>
+        </p:txBody>
+      </p:sp>
+      <p:sp>
+        <p:nvSpPr>
+          <p:cNvPr id="70" name="C1-E13 text 68" descr="sci-ppt:o068"/>
           <p:cNvSpPr txBox="1"/>
           <p:nvPr/>
         </p:nvSpPr>
@@ -5255,7 +6279,7 @@
                 </a:solidFill>
                 <a:latin typeface="Arial"/>
               </a:rPr>
-              <a:t>R(t) from the quadrature of Eq. C1-E16; Rₘₐₓ = 30 µm, ρ = 1000 kg/m³, Δp_c = 100 kPa.</a:t>
+              <a:t>Curves are y = Ṙ² and R³y from Eqs. C1-E13 and C1-E14 (scaled as labelled).</a:t>
             </a:r>
           </a:p>
         </p:txBody>

</xml_diff>